<commit_message>
add Limitations / Future Work slide (slide 14) to presentation
Inserted before The Team slide, matching the Design Decisions grid style:
2-column, 3-row numbered card layout. Left column: static cache, English-only
news, unverified narrative. Right column: scheduled refresh, on-demand entity
coverage, private source integration.

https://claude.ai/code/session_01TpWxFgZujd5gMFQW5VuSoy
</commit_message>
<xml_diff>
--- a/docs/osint-swarm-architecture.pptx
+++ b/docs/osint-swarm-architecture.pptx
@@ -18,6 +18,7 @@
     <p:sldId id="266" r:id="rId12"/>
     <p:sldId id="267" r:id="rId13"/>
     <p:sldId id="268" r:id="rId14"/>
+    <p:sldId id="270" r:id="rId21"/>
     <p:sldId id="269" r:id="rId15"/>
   </p:sldIdLst>
   <p:notesMasterIdLst>
@@ -10638,6 +10639,1373 @@
 </p:sld>
 </file>
 
+<file path=ppt/slides/slide15.xml><?xml version="1.0" encoding="utf-8"?>
+<p:sld xmlns:a="http://schemas.openxmlformats.org/drawingml/2006/main" xmlns:p="http://schemas.openxmlformats.org/presentationml/2006/main" xmlns:r="http://schemas.openxmlformats.org/officeDocument/2006/relationships">
+  <p:cSld>
+    <p:bg>
+      <p:bgPr>
+        <a:solidFill>
+          <a:srgbClr val="0F1923"/>
+        </a:solidFill>
+        <a:effectLst/>
+      </p:bgPr>
+    </p:bg>
+    <p:spTree>
+      <p:nvGrpSpPr>
+        <p:cNvPr id="1" name=""/>
+        <p:cNvGrpSpPr/>
+        <p:nvPr/>
+      </p:nvGrpSpPr>
+      <p:grpSpPr/>
+      <p:sp>
+        <p:nvSpPr>
+          <p:cNvPr id="2" name="Rectangle 1"/>
+          <p:cNvSpPr/>
+          <p:nvPr/>
+        </p:nvSpPr>
+        <p:spPr>
+          <a:xfrm>
+            <a:off x="0" y="0"/>
+            <a:ext cx="9144000" cy="54864"/>
+          </a:xfrm>
+          <a:prstGeom prst="rect">
+            <a:avLst/>
+          </a:prstGeom>
+          <a:solidFill>
+            <a:srgbClr val="00B4D8"/>
+          </a:solidFill>
+          <a:ln>
+            <a:noFill/>
+          </a:ln>
+        </p:spPr>
+        <p:style>
+          <a:lnRef idx="1">
+            <a:schemeClr val="accent1"/>
+          </a:lnRef>
+          <a:fillRef idx="3">
+            <a:schemeClr val="accent1"/>
+          </a:fillRef>
+          <a:effectRef idx="2">
+            <a:schemeClr val="accent1"/>
+          </a:effectRef>
+          <a:fontRef idx="minor">
+            <a:schemeClr val="lt1"/>
+          </a:fontRef>
+        </p:style>
+        <p:txBody>
+          <a:bodyPr rtlCol="0" anchor="ctr"/>
+          <a:lstStyle/>
+          <a:p>
+            <a:pPr algn="ctr"/>
+          </a:p>
+        </p:txBody>
+      </p:sp>
+      <p:sp>
+        <p:nvSpPr>
+          <p:cNvPr id="3" name="TextBox 2"/>
+          <p:cNvSpPr txBox="1"/>
+          <p:nvPr/>
+        </p:nvSpPr>
+        <p:spPr>
+          <a:xfrm>
+            <a:off x="640080" y="182880"/>
+            <a:ext cx="7315200" cy="320040"/>
+          </a:xfrm>
+          <a:prstGeom prst="rect">
+            <a:avLst/>
+          </a:prstGeom>
+          <a:noFill/>
+        </p:spPr>
+        <p:txBody>
+          <a:bodyPr wrap="square">
+            <a:spAutoFit/>
+          </a:bodyPr>
+          <a:lstStyle/>
+          <a:p>
+            <a:pPr algn="l"/>
+            <a:r>
+              <a:rPr b="1" sz="1100">
+                <a:solidFill>
+                  <a:srgbClr val="0077B6"/>
+                </a:solidFill>
+              </a:rPr>
+              <a:t>LIMITATIONS  ·  FUTURE WORK</a:t>
+            </a:r>
+          </a:p>
+        </p:txBody>
+      </p:sp>
+      <p:sp>
+        <p:nvSpPr>
+          <p:cNvPr id="4" name="TextBox 3"/>
+          <p:cNvSpPr txBox="1"/>
+          <p:nvPr/>
+        </p:nvSpPr>
+        <p:spPr>
+          <a:xfrm>
+            <a:off x="640080" y="457200"/>
+            <a:ext cx="7863840" cy="411480"/>
+          </a:xfrm>
+          <a:prstGeom prst="rect">
+            <a:avLst/>
+          </a:prstGeom>
+          <a:noFill/>
+        </p:spPr>
+        <p:txBody>
+          <a:bodyPr wrap="square">
+            <a:spAutoFit/>
+          </a:bodyPr>
+          <a:lstStyle/>
+          <a:p>
+            <a:pPr algn="l"/>
+            <a:r>
+              <a:rPr b="1" sz="2200">
+                <a:solidFill>
+                  <a:srgbClr val="FFFFFF"/>
+                </a:solidFill>
+              </a:rPr>
+              <a:t>What we'd change — and where we'd go next.</a:t>
+            </a:r>
+          </a:p>
+        </p:txBody>
+      </p:sp>
+      <p:sp>
+        <p:nvSpPr>
+          <p:cNvPr id="5" name="TextBox 4"/>
+          <p:cNvSpPr txBox="1"/>
+          <p:nvPr/>
+        </p:nvSpPr>
+        <p:spPr>
+          <a:xfrm>
+            <a:off x="457200" y="868680"/>
+            <a:ext cx="4114800" cy="228600"/>
+          </a:xfrm>
+          <a:prstGeom prst="rect">
+            <a:avLst/>
+          </a:prstGeom>
+          <a:noFill/>
+        </p:spPr>
+        <p:txBody>
+          <a:bodyPr wrap="square">
+            <a:spAutoFit/>
+          </a:bodyPr>
+          <a:lstStyle/>
+          <a:p>
+            <a:pPr algn="l"/>
+            <a:r>
+              <a:rPr b="1" sz="900">
+                <a:solidFill>
+                  <a:srgbClr val="00B4D8"/>
+                </a:solidFill>
+              </a:rPr>
+              <a:t>LIMITATIONS</a:t>
+            </a:r>
+          </a:p>
+        </p:txBody>
+      </p:sp>
+      <p:sp>
+        <p:nvSpPr>
+          <p:cNvPr id="6" name="TextBox 5"/>
+          <p:cNvSpPr txBox="1"/>
+          <p:nvPr/>
+        </p:nvSpPr>
+        <p:spPr>
+          <a:xfrm>
+            <a:off x="4846320" y="868680"/>
+            <a:ext cx="4114800" cy="228600"/>
+          </a:xfrm>
+          <a:prstGeom prst="rect">
+            <a:avLst/>
+          </a:prstGeom>
+          <a:noFill/>
+        </p:spPr>
+        <p:txBody>
+          <a:bodyPr wrap="square">
+            <a:spAutoFit/>
+          </a:bodyPr>
+          <a:lstStyle/>
+          <a:p>
+            <a:pPr algn="l"/>
+            <a:r>
+              <a:rPr b="1" sz="900">
+                <a:solidFill>
+                  <a:srgbClr val="00B4D8"/>
+                </a:solidFill>
+              </a:rPr>
+              <a:t>FUTURE WORK</a:t>
+            </a:r>
+          </a:p>
+        </p:txBody>
+      </p:sp>
+      <p:sp>
+        <p:nvSpPr>
+          <p:cNvPr id="7" name="Rectangle 6"/>
+          <p:cNvSpPr/>
+          <p:nvPr/>
+        </p:nvSpPr>
+        <p:spPr>
+          <a:xfrm>
+            <a:off x="457200" y="1143000"/>
+            <a:ext cx="4114800" cy="1097280"/>
+          </a:xfrm>
+          <a:prstGeom prst="rect">
+            <a:avLst/>
+          </a:prstGeom>
+          <a:solidFill>
+            <a:srgbClr val="1E3A52"/>
+          </a:solidFill>
+          <a:ln>
+            <a:noFill/>
+          </a:ln>
+        </p:spPr>
+        <p:style>
+          <a:lnRef idx="1">
+            <a:schemeClr val="accent1"/>
+          </a:lnRef>
+          <a:fillRef idx="3">
+            <a:schemeClr val="accent1"/>
+          </a:fillRef>
+          <a:effectRef idx="2">
+            <a:schemeClr val="accent1"/>
+          </a:effectRef>
+          <a:fontRef idx="minor">
+            <a:schemeClr val="lt1"/>
+          </a:fontRef>
+        </p:style>
+        <p:txBody>
+          <a:bodyPr rtlCol="0" anchor="ctr"/>
+          <a:lstStyle/>
+          <a:p>
+            <a:pPr algn="ctr"/>
+          </a:p>
+        </p:txBody>
+      </p:sp>
+      <p:sp>
+        <p:nvSpPr>
+          <p:cNvPr id="8" name="Rectangle 7"/>
+          <p:cNvSpPr/>
+          <p:nvPr/>
+        </p:nvSpPr>
+        <p:spPr>
+          <a:xfrm>
+            <a:off x="594360" y="1280160"/>
+            <a:ext cx="457200" cy="457200"/>
+          </a:xfrm>
+          <a:prstGeom prst="rect">
+            <a:avLst/>
+          </a:prstGeom>
+          <a:solidFill>
+            <a:srgbClr val="00B4D8"/>
+          </a:solidFill>
+          <a:ln>
+            <a:noFill/>
+          </a:ln>
+        </p:spPr>
+        <p:style>
+          <a:lnRef idx="1">
+            <a:schemeClr val="accent1"/>
+          </a:lnRef>
+          <a:fillRef idx="3">
+            <a:schemeClr val="accent1"/>
+          </a:fillRef>
+          <a:effectRef idx="2">
+            <a:schemeClr val="accent1"/>
+          </a:effectRef>
+          <a:fontRef idx="minor">
+            <a:schemeClr val="lt1"/>
+          </a:fontRef>
+        </p:style>
+        <p:txBody>
+          <a:bodyPr rtlCol="0" anchor="ctr"/>
+          <a:lstStyle/>
+          <a:p>
+            <a:pPr algn="ctr"/>
+          </a:p>
+        </p:txBody>
+      </p:sp>
+      <p:sp>
+        <p:nvSpPr>
+          <p:cNvPr id="9" name="TextBox 8"/>
+          <p:cNvSpPr txBox="1"/>
+          <p:nvPr/>
+        </p:nvSpPr>
+        <p:spPr>
+          <a:xfrm>
+            <a:off x="594360" y="1280160"/>
+            <a:ext cx="457200" cy="457200"/>
+          </a:xfrm>
+          <a:prstGeom prst="rect">
+            <a:avLst/>
+          </a:prstGeom>
+          <a:noFill/>
+        </p:spPr>
+        <p:txBody>
+          <a:bodyPr wrap="square">
+            <a:spAutoFit/>
+          </a:bodyPr>
+          <a:lstStyle/>
+          <a:p>
+            <a:pPr algn="ctr"/>
+            <a:r>
+              <a:rPr b="1" sz="1200">
+                <a:solidFill>
+                  <a:srgbClr val="0F1923"/>
+                </a:solidFill>
+              </a:rPr>
+              <a:t>01</a:t>
+            </a:r>
+          </a:p>
+        </p:txBody>
+      </p:sp>
+      <p:sp>
+        <p:nvSpPr>
+          <p:cNvPr id="10" name="TextBox 9"/>
+          <p:cNvSpPr txBox="1"/>
+          <p:nvPr/>
+        </p:nvSpPr>
+        <p:spPr>
+          <a:xfrm>
+            <a:off x="1143000" y="1234440"/>
+            <a:ext cx="3200400" cy="365760"/>
+          </a:xfrm>
+          <a:prstGeom prst="rect">
+            <a:avLst/>
+          </a:prstGeom>
+          <a:noFill/>
+        </p:spPr>
+        <p:txBody>
+          <a:bodyPr wrap="square">
+            <a:spAutoFit/>
+          </a:bodyPr>
+          <a:lstStyle/>
+          <a:p>
+            <a:pPr algn="l"/>
+            <a:r>
+              <a:rPr b="1" sz="1200">
+                <a:solidFill>
+                  <a:srgbClr val="FFFFFF"/>
+                </a:solidFill>
+              </a:rPr>
+              <a:t>Static data cache</a:t>
+            </a:r>
+          </a:p>
+        </p:txBody>
+      </p:sp>
+      <p:sp>
+        <p:nvSpPr>
+          <p:cNvPr id="11" name="TextBox 10"/>
+          <p:cNvSpPr txBox="1"/>
+          <p:nvPr/>
+        </p:nvSpPr>
+        <p:spPr>
+          <a:xfrm>
+            <a:off x="1143000" y="1600200"/>
+            <a:ext cx="3200400" cy="548640"/>
+          </a:xfrm>
+          <a:prstGeom prst="rect">
+            <a:avLst/>
+          </a:prstGeom>
+          <a:noFill/>
+        </p:spPr>
+        <p:txBody>
+          <a:bodyPr wrap="square">
+            <a:spAutoFit/>
+          </a:bodyPr>
+          <a:lstStyle/>
+          <a:p>
+            <a:pPr algn="l"/>
+            <a:r>
+              <a:rPr b="0" sz="1000">
+                <a:solidFill>
+                  <a:srgbClr val="CBD5E1"/>
+                </a:solidFill>
+              </a:rPr>
+              <a:t>Evidence reflects the last pull date. OFAC, court records, and GDELT go stale without a manual refresh.</a:t>
+            </a:r>
+          </a:p>
+        </p:txBody>
+      </p:sp>
+      <p:sp>
+        <p:nvSpPr>
+          <p:cNvPr id="12" name="Rectangle 11"/>
+          <p:cNvSpPr/>
+          <p:nvPr/>
+        </p:nvSpPr>
+        <p:spPr>
+          <a:xfrm>
+            <a:off x="457200" y="2377440"/>
+            <a:ext cx="4114800" cy="1097280"/>
+          </a:xfrm>
+          <a:prstGeom prst="rect">
+            <a:avLst/>
+          </a:prstGeom>
+          <a:solidFill>
+            <a:srgbClr val="1E3A52"/>
+          </a:solidFill>
+          <a:ln>
+            <a:noFill/>
+          </a:ln>
+        </p:spPr>
+        <p:style>
+          <a:lnRef idx="1">
+            <a:schemeClr val="accent1"/>
+          </a:lnRef>
+          <a:fillRef idx="3">
+            <a:schemeClr val="accent1"/>
+          </a:fillRef>
+          <a:effectRef idx="2">
+            <a:schemeClr val="accent1"/>
+          </a:effectRef>
+          <a:fontRef idx="minor">
+            <a:schemeClr val="lt1"/>
+          </a:fontRef>
+        </p:style>
+        <p:txBody>
+          <a:bodyPr rtlCol="0" anchor="ctr"/>
+          <a:lstStyle/>
+          <a:p>
+            <a:pPr algn="ctr"/>
+          </a:p>
+        </p:txBody>
+      </p:sp>
+      <p:sp>
+        <p:nvSpPr>
+          <p:cNvPr id="13" name="Rectangle 12"/>
+          <p:cNvSpPr/>
+          <p:nvPr/>
+        </p:nvSpPr>
+        <p:spPr>
+          <a:xfrm>
+            <a:off x="594360" y="2514600"/>
+            <a:ext cx="457200" cy="457200"/>
+          </a:xfrm>
+          <a:prstGeom prst="rect">
+            <a:avLst/>
+          </a:prstGeom>
+          <a:solidFill>
+            <a:srgbClr val="00B4D8"/>
+          </a:solidFill>
+          <a:ln>
+            <a:noFill/>
+          </a:ln>
+        </p:spPr>
+        <p:style>
+          <a:lnRef idx="1">
+            <a:schemeClr val="accent1"/>
+          </a:lnRef>
+          <a:fillRef idx="3">
+            <a:schemeClr val="accent1"/>
+          </a:fillRef>
+          <a:effectRef idx="2">
+            <a:schemeClr val="accent1"/>
+          </a:effectRef>
+          <a:fontRef idx="minor">
+            <a:schemeClr val="lt1"/>
+          </a:fontRef>
+        </p:style>
+        <p:txBody>
+          <a:bodyPr rtlCol="0" anchor="ctr"/>
+          <a:lstStyle/>
+          <a:p>
+            <a:pPr algn="ctr"/>
+          </a:p>
+        </p:txBody>
+      </p:sp>
+      <p:sp>
+        <p:nvSpPr>
+          <p:cNvPr id="14" name="TextBox 13"/>
+          <p:cNvSpPr txBox="1"/>
+          <p:nvPr/>
+        </p:nvSpPr>
+        <p:spPr>
+          <a:xfrm>
+            <a:off x="594360" y="2514600"/>
+            <a:ext cx="457200" cy="457200"/>
+          </a:xfrm>
+          <a:prstGeom prst="rect">
+            <a:avLst/>
+          </a:prstGeom>
+          <a:noFill/>
+        </p:spPr>
+        <p:txBody>
+          <a:bodyPr wrap="square">
+            <a:spAutoFit/>
+          </a:bodyPr>
+          <a:lstStyle/>
+          <a:p>
+            <a:pPr algn="ctr"/>
+            <a:r>
+              <a:rPr b="1" sz="1200">
+                <a:solidFill>
+                  <a:srgbClr val="0F1923"/>
+                </a:solidFill>
+              </a:rPr>
+              <a:t>02</a:t>
+            </a:r>
+          </a:p>
+        </p:txBody>
+      </p:sp>
+      <p:sp>
+        <p:nvSpPr>
+          <p:cNvPr id="15" name="TextBox 14"/>
+          <p:cNvSpPr txBox="1"/>
+          <p:nvPr/>
+        </p:nvSpPr>
+        <p:spPr>
+          <a:xfrm>
+            <a:off x="1143000" y="2468880"/>
+            <a:ext cx="3200400" cy="365760"/>
+          </a:xfrm>
+          <a:prstGeom prst="rect">
+            <a:avLst/>
+          </a:prstGeom>
+          <a:noFill/>
+        </p:spPr>
+        <p:txBody>
+          <a:bodyPr wrap="square">
+            <a:spAutoFit/>
+          </a:bodyPr>
+          <a:lstStyle/>
+          <a:p>
+            <a:pPr algn="l"/>
+            <a:r>
+              <a:rPr b="1" sz="1200">
+                <a:solidFill>
+                  <a:srgbClr val="FFFFFF"/>
+                </a:solidFill>
+              </a:rPr>
+              <a:t>English-only news signal</a:t>
+            </a:r>
+          </a:p>
+        </p:txBody>
+      </p:sp>
+      <p:sp>
+        <p:nvSpPr>
+          <p:cNvPr id="16" name="TextBox 15"/>
+          <p:cNvSpPr txBox="1"/>
+          <p:nvPr/>
+        </p:nvSpPr>
+        <p:spPr>
+          <a:xfrm>
+            <a:off x="1143000" y="2834640"/>
+            <a:ext cx="3200400" cy="548640"/>
+          </a:xfrm>
+          <a:prstGeom prst="rect">
+            <a:avLst/>
+          </a:prstGeom>
+          <a:noFill/>
+        </p:spPr>
+        <p:txBody>
+          <a:bodyPr wrap="square">
+            <a:spAutoFit/>
+          </a:bodyPr>
+          <a:lstStyle/>
+          <a:p>
+            <a:pPr algn="l"/>
+            <a:r>
+              <a:rPr b="0" sz="1000">
+                <a:solidFill>
+                  <a:srgbClr val="CBD5E1"/>
+                </a:solidFill>
+              </a:rPr>
+              <a:t>GDELT is filtered to English articles only. International adverse media in other languages is not captured.</a:t>
+            </a:r>
+          </a:p>
+        </p:txBody>
+      </p:sp>
+      <p:sp>
+        <p:nvSpPr>
+          <p:cNvPr id="17" name="Rectangle 16"/>
+          <p:cNvSpPr/>
+          <p:nvPr/>
+        </p:nvSpPr>
+        <p:spPr>
+          <a:xfrm>
+            <a:off x="457200" y="3611880"/>
+            <a:ext cx="4114800" cy="1097280"/>
+          </a:xfrm>
+          <a:prstGeom prst="rect">
+            <a:avLst/>
+          </a:prstGeom>
+          <a:solidFill>
+            <a:srgbClr val="1E3A52"/>
+          </a:solidFill>
+          <a:ln>
+            <a:noFill/>
+          </a:ln>
+        </p:spPr>
+        <p:style>
+          <a:lnRef idx="1">
+            <a:schemeClr val="accent1"/>
+          </a:lnRef>
+          <a:fillRef idx="3">
+            <a:schemeClr val="accent1"/>
+          </a:fillRef>
+          <a:effectRef idx="2">
+            <a:schemeClr val="accent1"/>
+          </a:effectRef>
+          <a:fontRef idx="minor">
+            <a:schemeClr val="lt1"/>
+          </a:fontRef>
+        </p:style>
+        <p:txBody>
+          <a:bodyPr rtlCol="0" anchor="ctr"/>
+          <a:lstStyle/>
+          <a:p>
+            <a:pPr algn="ctr"/>
+          </a:p>
+        </p:txBody>
+      </p:sp>
+      <p:sp>
+        <p:nvSpPr>
+          <p:cNvPr id="18" name="Rectangle 17"/>
+          <p:cNvSpPr/>
+          <p:nvPr/>
+        </p:nvSpPr>
+        <p:spPr>
+          <a:xfrm>
+            <a:off x="594360" y="3749040"/>
+            <a:ext cx="457200" cy="457200"/>
+          </a:xfrm>
+          <a:prstGeom prst="rect">
+            <a:avLst/>
+          </a:prstGeom>
+          <a:solidFill>
+            <a:srgbClr val="00B4D8"/>
+          </a:solidFill>
+          <a:ln>
+            <a:noFill/>
+          </a:ln>
+        </p:spPr>
+        <p:style>
+          <a:lnRef idx="1">
+            <a:schemeClr val="accent1"/>
+          </a:lnRef>
+          <a:fillRef idx="3">
+            <a:schemeClr val="accent1"/>
+          </a:fillRef>
+          <a:effectRef idx="2">
+            <a:schemeClr val="accent1"/>
+          </a:effectRef>
+          <a:fontRef idx="minor">
+            <a:schemeClr val="lt1"/>
+          </a:fontRef>
+        </p:style>
+        <p:txBody>
+          <a:bodyPr rtlCol="0" anchor="ctr"/>
+          <a:lstStyle/>
+          <a:p>
+            <a:pPr algn="ctr"/>
+          </a:p>
+        </p:txBody>
+      </p:sp>
+      <p:sp>
+        <p:nvSpPr>
+          <p:cNvPr id="19" name="TextBox 18"/>
+          <p:cNvSpPr txBox="1"/>
+          <p:nvPr/>
+        </p:nvSpPr>
+        <p:spPr>
+          <a:xfrm>
+            <a:off x="594360" y="3749040"/>
+            <a:ext cx="457200" cy="457200"/>
+          </a:xfrm>
+          <a:prstGeom prst="rect">
+            <a:avLst/>
+          </a:prstGeom>
+          <a:noFill/>
+        </p:spPr>
+        <p:txBody>
+          <a:bodyPr wrap="square">
+            <a:spAutoFit/>
+          </a:bodyPr>
+          <a:lstStyle/>
+          <a:p>
+            <a:pPr algn="ctr"/>
+            <a:r>
+              <a:rPr b="1" sz="1200">
+                <a:solidFill>
+                  <a:srgbClr val="0F1923"/>
+                </a:solidFill>
+              </a:rPr>
+              <a:t>03</a:t>
+            </a:r>
+          </a:p>
+        </p:txBody>
+      </p:sp>
+      <p:sp>
+        <p:nvSpPr>
+          <p:cNvPr id="20" name="TextBox 19"/>
+          <p:cNvSpPr txBox="1"/>
+          <p:nvPr/>
+        </p:nvSpPr>
+        <p:spPr>
+          <a:xfrm>
+            <a:off x="1143000" y="3703320"/>
+            <a:ext cx="3200400" cy="365760"/>
+          </a:xfrm>
+          <a:prstGeom prst="rect">
+            <a:avLst/>
+          </a:prstGeom>
+          <a:noFill/>
+        </p:spPr>
+        <p:txBody>
+          <a:bodyPr wrap="square">
+            <a:spAutoFit/>
+          </a:bodyPr>
+          <a:lstStyle/>
+          <a:p>
+            <a:pPr algn="l"/>
+            <a:r>
+              <a:rPr b="1" sz="1200">
+                <a:solidFill>
+                  <a:srgbClr val="FFFFFF"/>
+                </a:solidFill>
+              </a:rPr>
+              <a:t>Narrative not formally verified</a:t>
+            </a:r>
+          </a:p>
+        </p:txBody>
+      </p:sp>
+      <p:sp>
+        <p:nvSpPr>
+          <p:cNvPr id="21" name="TextBox 20"/>
+          <p:cNvSpPr txBox="1"/>
+          <p:nvPr/>
+        </p:nvSpPr>
+        <p:spPr>
+          <a:xfrm>
+            <a:off x="1143000" y="4069080"/>
+            <a:ext cx="3200400" cy="548640"/>
+          </a:xfrm>
+          <a:prstGeom prst="rect">
+            <a:avLst/>
+          </a:prstGeom>
+          <a:noFill/>
+        </p:spPr>
+        <p:txBody>
+          <a:bodyPr wrap="square">
+            <a:spAutoFit/>
+          </a:bodyPr>
+          <a:lstStyle/>
+          <a:p>
+            <a:pPr algn="l"/>
+            <a:r>
+              <a:rPr b="0" sz="1000">
+                <a:solidFill>
+                  <a:srgbClr val="CBD5E1"/>
+                </a:solidFill>
+              </a:rPr>
+              <a:t>The LLM narrative is contract-bound but not sentence-level cross-checked against individual evidence rows.</a:t>
+            </a:r>
+          </a:p>
+        </p:txBody>
+      </p:sp>
+      <p:sp>
+        <p:nvSpPr>
+          <p:cNvPr id="22" name="Rectangle 21"/>
+          <p:cNvSpPr/>
+          <p:nvPr/>
+        </p:nvSpPr>
+        <p:spPr>
+          <a:xfrm>
+            <a:off x="4846320" y="1143000"/>
+            <a:ext cx="4114800" cy="1097280"/>
+          </a:xfrm>
+          <a:prstGeom prst="rect">
+            <a:avLst/>
+          </a:prstGeom>
+          <a:solidFill>
+            <a:srgbClr val="1E3A52"/>
+          </a:solidFill>
+          <a:ln>
+            <a:noFill/>
+          </a:ln>
+        </p:spPr>
+        <p:style>
+          <a:lnRef idx="1">
+            <a:schemeClr val="accent1"/>
+          </a:lnRef>
+          <a:fillRef idx="3">
+            <a:schemeClr val="accent1"/>
+          </a:fillRef>
+          <a:effectRef idx="2">
+            <a:schemeClr val="accent1"/>
+          </a:effectRef>
+          <a:fontRef idx="minor">
+            <a:schemeClr val="lt1"/>
+          </a:fontRef>
+        </p:style>
+        <p:txBody>
+          <a:bodyPr rtlCol="0" anchor="ctr"/>
+          <a:lstStyle/>
+          <a:p>
+            <a:pPr algn="ctr"/>
+          </a:p>
+        </p:txBody>
+      </p:sp>
+      <p:sp>
+        <p:nvSpPr>
+          <p:cNvPr id="23" name="Rectangle 22"/>
+          <p:cNvSpPr/>
+          <p:nvPr/>
+        </p:nvSpPr>
+        <p:spPr>
+          <a:xfrm>
+            <a:off x="4983480" y="1280160"/>
+            <a:ext cx="457200" cy="457200"/>
+          </a:xfrm>
+          <a:prstGeom prst="rect">
+            <a:avLst/>
+          </a:prstGeom>
+          <a:solidFill>
+            <a:srgbClr val="00B4D8"/>
+          </a:solidFill>
+          <a:ln>
+            <a:noFill/>
+          </a:ln>
+        </p:spPr>
+        <p:style>
+          <a:lnRef idx="1">
+            <a:schemeClr val="accent1"/>
+          </a:lnRef>
+          <a:fillRef idx="3">
+            <a:schemeClr val="accent1"/>
+          </a:fillRef>
+          <a:effectRef idx="2">
+            <a:schemeClr val="accent1"/>
+          </a:effectRef>
+          <a:fontRef idx="minor">
+            <a:schemeClr val="lt1"/>
+          </a:fontRef>
+        </p:style>
+        <p:txBody>
+          <a:bodyPr rtlCol="0" anchor="ctr"/>
+          <a:lstStyle/>
+          <a:p>
+            <a:pPr algn="ctr"/>
+          </a:p>
+        </p:txBody>
+      </p:sp>
+      <p:sp>
+        <p:nvSpPr>
+          <p:cNvPr id="24" name="TextBox 23"/>
+          <p:cNvSpPr txBox="1"/>
+          <p:nvPr/>
+        </p:nvSpPr>
+        <p:spPr>
+          <a:xfrm>
+            <a:off x="4983480" y="1280160"/>
+            <a:ext cx="457200" cy="457200"/>
+          </a:xfrm>
+          <a:prstGeom prst="rect">
+            <a:avLst/>
+          </a:prstGeom>
+          <a:noFill/>
+        </p:spPr>
+        <p:txBody>
+          <a:bodyPr wrap="square">
+            <a:spAutoFit/>
+          </a:bodyPr>
+          <a:lstStyle/>
+          <a:p>
+            <a:pPr algn="ctr"/>
+            <a:r>
+              <a:rPr b="1" sz="1200">
+                <a:solidFill>
+                  <a:srgbClr val="0F1923"/>
+                </a:solidFill>
+              </a:rPr>
+              <a:t>04</a:t>
+            </a:r>
+          </a:p>
+        </p:txBody>
+      </p:sp>
+      <p:sp>
+        <p:nvSpPr>
+          <p:cNvPr id="25" name="TextBox 24"/>
+          <p:cNvSpPr txBox="1"/>
+          <p:nvPr/>
+        </p:nvSpPr>
+        <p:spPr>
+          <a:xfrm>
+            <a:off x="5532120" y="1234440"/>
+            <a:ext cx="3200400" cy="365760"/>
+          </a:xfrm>
+          <a:prstGeom prst="rect">
+            <a:avLst/>
+          </a:prstGeom>
+          <a:noFill/>
+        </p:spPr>
+        <p:txBody>
+          <a:bodyPr wrap="square">
+            <a:spAutoFit/>
+          </a:bodyPr>
+          <a:lstStyle/>
+          <a:p>
+            <a:pPr algn="l"/>
+            <a:r>
+              <a:rPr b="1" sz="1200">
+                <a:solidFill>
+                  <a:srgbClr val="FFFFFF"/>
+                </a:solidFill>
+              </a:rPr>
+              <a:t>Scheduled data refresh</a:t>
+            </a:r>
+          </a:p>
+        </p:txBody>
+      </p:sp>
+      <p:sp>
+        <p:nvSpPr>
+          <p:cNvPr id="26" name="TextBox 25"/>
+          <p:cNvSpPr txBox="1"/>
+          <p:nvPr/>
+        </p:nvSpPr>
+        <p:spPr>
+          <a:xfrm>
+            <a:off x="5532120" y="1600200"/>
+            <a:ext cx="3200400" cy="548640"/>
+          </a:xfrm>
+          <a:prstGeom prst="rect">
+            <a:avLst/>
+          </a:prstGeom>
+          <a:noFill/>
+        </p:spPr>
+        <p:txBody>
+          <a:bodyPr wrap="square">
+            <a:spAutoFit/>
+          </a:bodyPr>
+          <a:lstStyle/>
+          <a:p>
+            <a:pPr algn="l"/>
+            <a:r>
+              <a:rPr b="0" sz="1000">
+                <a:solidFill>
+                  <a:srgbClr val="CBD5E1"/>
+                </a:solidFill>
+              </a:rPr>
+              <a:t>Automate nightly pulls for all four sources so every investigation reflects the current day's data.</a:t>
+            </a:r>
+          </a:p>
+        </p:txBody>
+      </p:sp>
+      <p:sp>
+        <p:nvSpPr>
+          <p:cNvPr id="27" name="Rectangle 26"/>
+          <p:cNvSpPr/>
+          <p:nvPr/>
+        </p:nvSpPr>
+        <p:spPr>
+          <a:xfrm>
+            <a:off x="4846320" y="2377440"/>
+            <a:ext cx="4114800" cy="1097280"/>
+          </a:xfrm>
+          <a:prstGeom prst="rect">
+            <a:avLst/>
+          </a:prstGeom>
+          <a:solidFill>
+            <a:srgbClr val="1E3A52"/>
+          </a:solidFill>
+          <a:ln>
+            <a:noFill/>
+          </a:ln>
+        </p:spPr>
+        <p:style>
+          <a:lnRef idx="1">
+            <a:schemeClr val="accent1"/>
+          </a:lnRef>
+          <a:fillRef idx="3">
+            <a:schemeClr val="accent1"/>
+          </a:fillRef>
+          <a:effectRef idx="2">
+            <a:schemeClr val="accent1"/>
+          </a:effectRef>
+          <a:fontRef idx="minor">
+            <a:schemeClr val="lt1"/>
+          </a:fontRef>
+        </p:style>
+        <p:txBody>
+          <a:bodyPr rtlCol="0" anchor="ctr"/>
+          <a:lstStyle/>
+          <a:p>
+            <a:pPr algn="ctr"/>
+          </a:p>
+        </p:txBody>
+      </p:sp>
+      <p:sp>
+        <p:nvSpPr>
+          <p:cNvPr id="28" name="Rectangle 27"/>
+          <p:cNvSpPr/>
+          <p:nvPr/>
+        </p:nvSpPr>
+        <p:spPr>
+          <a:xfrm>
+            <a:off x="4983480" y="2514600"/>
+            <a:ext cx="457200" cy="457200"/>
+          </a:xfrm>
+          <a:prstGeom prst="rect">
+            <a:avLst/>
+          </a:prstGeom>
+          <a:solidFill>
+            <a:srgbClr val="00B4D8"/>
+          </a:solidFill>
+          <a:ln>
+            <a:noFill/>
+          </a:ln>
+        </p:spPr>
+        <p:style>
+          <a:lnRef idx="1">
+            <a:schemeClr val="accent1"/>
+          </a:lnRef>
+          <a:fillRef idx="3">
+            <a:schemeClr val="accent1"/>
+          </a:fillRef>
+          <a:effectRef idx="2">
+            <a:schemeClr val="accent1"/>
+          </a:effectRef>
+          <a:fontRef idx="minor">
+            <a:schemeClr val="lt1"/>
+          </a:fontRef>
+        </p:style>
+        <p:txBody>
+          <a:bodyPr rtlCol="0" anchor="ctr"/>
+          <a:lstStyle/>
+          <a:p>
+            <a:pPr algn="ctr"/>
+          </a:p>
+        </p:txBody>
+      </p:sp>
+      <p:sp>
+        <p:nvSpPr>
+          <p:cNvPr id="29" name="TextBox 28"/>
+          <p:cNvSpPr txBox="1"/>
+          <p:nvPr/>
+        </p:nvSpPr>
+        <p:spPr>
+          <a:xfrm>
+            <a:off x="4983480" y="2514600"/>
+            <a:ext cx="457200" cy="457200"/>
+          </a:xfrm>
+          <a:prstGeom prst="rect">
+            <a:avLst/>
+          </a:prstGeom>
+          <a:noFill/>
+        </p:spPr>
+        <p:txBody>
+          <a:bodyPr wrap="square">
+            <a:spAutoFit/>
+          </a:bodyPr>
+          <a:lstStyle/>
+          <a:p>
+            <a:pPr algn="ctr"/>
+            <a:r>
+              <a:rPr b="1" sz="1200">
+                <a:solidFill>
+                  <a:srgbClr val="0F1923"/>
+                </a:solidFill>
+              </a:rPr>
+              <a:t>05</a:t>
+            </a:r>
+          </a:p>
+        </p:txBody>
+      </p:sp>
+      <p:sp>
+        <p:nvSpPr>
+          <p:cNvPr id="30" name="TextBox 29"/>
+          <p:cNvSpPr txBox="1"/>
+          <p:nvPr/>
+        </p:nvSpPr>
+        <p:spPr>
+          <a:xfrm>
+            <a:off x="5532120" y="2468880"/>
+            <a:ext cx="3200400" cy="365760"/>
+          </a:xfrm>
+          <a:prstGeom prst="rect">
+            <a:avLst/>
+          </a:prstGeom>
+          <a:noFill/>
+        </p:spPr>
+        <p:txBody>
+          <a:bodyPr wrap="square">
+            <a:spAutoFit/>
+          </a:bodyPr>
+          <a:lstStyle/>
+          <a:p>
+            <a:pPr algn="l"/>
+            <a:r>
+              <a:rPr b="1" sz="1200">
+                <a:solidFill>
+                  <a:srgbClr val="FFFFFF"/>
+                </a:solidFill>
+              </a:rPr>
+              <a:t>On-demand entity coverage</a:t>
+            </a:r>
+          </a:p>
+        </p:txBody>
+      </p:sp>
+      <p:sp>
+        <p:nvSpPr>
+          <p:cNvPr id="31" name="TextBox 30"/>
+          <p:cNvSpPr txBox="1"/>
+          <p:nvPr/>
+        </p:nvSpPr>
+        <p:spPr>
+          <a:xfrm>
+            <a:off x="5532120" y="2834640"/>
+            <a:ext cx="3200400" cy="548640"/>
+          </a:xfrm>
+          <a:prstGeom prst="rect">
+            <a:avLst/>
+          </a:prstGeom>
+          <a:noFill/>
+        </p:spPr>
+        <p:txBody>
+          <a:bodyPr wrap="square">
+            <a:spAutoFit/>
+          </a:bodyPr>
+          <a:lstStyle/>
+          <a:p>
+            <a:pPr algn="l"/>
+            <a:r>
+              <a:rPr b="0" sz="1000">
+                <a:solidFill>
+                  <a:srgbClr val="CBD5E1"/>
+                </a:solidFill>
+              </a:rPr>
+              <a:t>Resolve and pull any public company at query time via SEC EDGAR, removing the five-entity cache limit.</a:t>
+            </a:r>
+          </a:p>
+        </p:txBody>
+      </p:sp>
+      <p:sp>
+        <p:nvSpPr>
+          <p:cNvPr id="32" name="Rectangle 31"/>
+          <p:cNvSpPr/>
+          <p:nvPr/>
+        </p:nvSpPr>
+        <p:spPr>
+          <a:xfrm>
+            <a:off x="4846320" y="3611880"/>
+            <a:ext cx="4114800" cy="1097280"/>
+          </a:xfrm>
+          <a:prstGeom prst="rect">
+            <a:avLst/>
+          </a:prstGeom>
+          <a:solidFill>
+            <a:srgbClr val="1E3A52"/>
+          </a:solidFill>
+          <a:ln>
+            <a:noFill/>
+          </a:ln>
+        </p:spPr>
+        <p:style>
+          <a:lnRef idx="1">
+            <a:schemeClr val="accent1"/>
+          </a:lnRef>
+          <a:fillRef idx="3">
+            <a:schemeClr val="accent1"/>
+          </a:fillRef>
+          <a:effectRef idx="2">
+            <a:schemeClr val="accent1"/>
+          </a:effectRef>
+          <a:fontRef idx="minor">
+            <a:schemeClr val="lt1"/>
+          </a:fontRef>
+        </p:style>
+        <p:txBody>
+          <a:bodyPr rtlCol="0" anchor="ctr"/>
+          <a:lstStyle/>
+          <a:p>
+            <a:pPr algn="ctr"/>
+          </a:p>
+        </p:txBody>
+      </p:sp>
+      <p:sp>
+        <p:nvSpPr>
+          <p:cNvPr id="33" name="Rectangle 32"/>
+          <p:cNvSpPr/>
+          <p:nvPr/>
+        </p:nvSpPr>
+        <p:spPr>
+          <a:xfrm>
+            <a:off x="4983480" y="3749040"/>
+            <a:ext cx="457200" cy="457200"/>
+          </a:xfrm>
+          <a:prstGeom prst="rect">
+            <a:avLst/>
+          </a:prstGeom>
+          <a:solidFill>
+            <a:srgbClr val="00B4D8"/>
+          </a:solidFill>
+          <a:ln>
+            <a:noFill/>
+          </a:ln>
+        </p:spPr>
+        <p:style>
+          <a:lnRef idx="1">
+            <a:schemeClr val="accent1"/>
+          </a:lnRef>
+          <a:fillRef idx="3">
+            <a:schemeClr val="accent1"/>
+          </a:fillRef>
+          <a:effectRef idx="2">
+            <a:schemeClr val="accent1"/>
+          </a:effectRef>
+          <a:fontRef idx="minor">
+            <a:schemeClr val="lt1"/>
+          </a:fontRef>
+        </p:style>
+        <p:txBody>
+          <a:bodyPr rtlCol="0" anchor="ctr"/>
+          <a:lstStyle/>
+          <a:p>
+            <a:pPr algn="ctr"/>
+          </a:p>
+        </p:txBody>
+      </p:sp>
+      <p:sp>
+        <p:nvSpPr>
+          <p:cNvPr id="34" name="TextBox 33"/>
+          <p:cNvSpPr txBox="1"/>
+          <p:nvPr/>
+        </p:nvSpPr>
+        <p:spPr>
+          <a:xfrm>
+            <a:off x="4983480" y="3749040"/>
+            <a:ext cx="457200" cy="457200"/>
+          </a:xfrm>
+          <a:prstGeom prst="rect">
+            <a:avLst/>
+          </a:prstGeom>
+          <a:noFill/>
+        </p:spPr>
+        <p:txBody>
+          <a:bodyPr wrap="square">
+            <a:spAutoFit/>
+          </a:bodyPr>
+          <a:lstStyle/>
+          <a:p>
+            <a:pPr algn="ctr"/>
+            <a:r>
+              <a:rPr b="1" sz="1200">
+                <a:solidFill>
+                  <a:srgbClr val="0F1923"/>
+                </a:solidFill>
+              </a:rPr>
+              <a:t>06</a:t>
+            </a:r>
+          </a:p>
+        </p:txBody>
+      </p:sp>
+      <p:sp>
+        <p:nvSpPr>
+          <p:cNvPr id="35" name="TextBox 34"/>
+          <p:cNvSpPr txBox="1"/>
+          <p:nvPr/>
+        </p:nvSpPr>
+        <p:spPr>
+          <a:xfrm>
+            <a:off x="5532120" y="3703320"/>
+            <a:ext cx="3200400" cy="365760"/>
+          </a:xfrm>
+          <a:prstGeom prst="rect">
+            <a:avLst/>
+          </a:prstGeom>
+          <a:noFill/>
+        </p:spPr>
+        <p:txBody>
+          <a:bodyPr wrap="square">
+            <a:spAutoFit/>
+          </a:bodyPr>
+          <a:lstStyle/>
+          <a:p>
+            <a:pPr algn="l"/>
+            <a:r>
+              <a:rPr b="1" sz="1200">
+                <a:solidFill>
+                  <a:srgbClr val="FFFFFF"/>
+                </a:solidFill>
+              </a:rPr>
+              <a:t>Private source integration</a:t>
+            </a:r>
+          </a:p>
+        </p:txBody>
+      </p:sp>
+      <p:sp>
+        <p:nvSpPr>
+          <p:cNvPr id="36" name="TextBox 35"/>
+          <p:cNvSpPr txBox="1"/>
+          <p:nvPr/>
+        </p:nvSpPr>
+        <p:spPr>
+          <a:xfrm>
+            <a:off x="5532120" y="4069080"/>
+            <a:ext cx="3200400" cy="548640"/>
+          </a:xfrm>
+          <a:prstGeom prst="rect">
+            <a:avLst/>
+          </a:prstGeom>
+          <a:noFill/>
+        </p:spPr>
+        <p:txBody>
+          <a:bodyPr wrap="square">
+            <a:spAutoFit/>
+          </a:bodyPr>
+          <a:lstStyle/>
+          <a:p>
+            <a:pPr algn="l"/>
+            <a:r>
+              <a:rPr b="0" sz="1000">
+                <a:solidFill>
+                  <a:srgbClr val="CBD5E1"/>
+                </a:solidFill>
+              </a:rPr>
+              <a:t>Add licensed data (OpenCorporates, Dun &amp; Bradstreet) to support non-public and international entities.</a:t>
+            </a:r>
+          </a:p>
+        </p:txBody>
+      </p:sp>
+      <p:sp>
+        <p:nvSpPr>
+          <p:cNvPr id="37" name="TextBox 36"/>
+          <p:cNvSpPr txBox="1"/>
+          <p:nvPr/>
+        </p:nvSpPr>
+        <p:spPr>
+          <a:xfrm>
+            <a:off x="8229600" y="4709160"/>
+            <a:ext cx="640080" cy="274320"/>
+          </a:xfrm>
+          <a:prstGeom prst="rect">
+            <a:avLst/>
+          </a:prstGeom>
+          <a:noFill/>
+        </p:spPr>
+        <p:txBody>
+          <a:bodyPr wrap="square">
+            <a:spAutoFit/>
+          </a:bodyPr>
+          <a:lstStyle/>
+          <a:p>
+            <a:pPr algn="r"/>
+            <a:r>
+              <a:rPr b="0" sz="1000">
+                <a:solidFill>
+                  <a:srgbClr val="64748B"/>
+                </a:solidFill>
+              </a:rPr>
+              <a:t>14</a:t>
+            </a:r>
+          </a:p>
+        </p:txBody>
+      </p:sp>
+    </p:spTree>
+  </p:cSld>
+  <p:clrMapOvr>
+    <a:masterClrMapping/>
+  </p:clrMapOvr>
+</p:sld>
+</file>
+
 <file path=ppt/slides/slide2.xml><?xml version="1.0" encoding="utf-8"?>
 <p:sld xmlns:a="http://schemas.openxmlformats.org/drawingml/2006/main" xmlns:r="http://schemas.openxmlformats.org/officeDocument/2006/relationships" xmlns:p="http://schemas.openxmlformats.org/presentationml/2006/main">
   <p:cSld name="Slide 2">

</xml_diff>

<commit_message>
add Conclusion slide (slide 15) and update speaker notes
Three full-width stacked cards — What We Built, What We Proved,
What's Next — inserted before The Team (now slide 16). Matches
deck colour palette and layout. Speaker notes updated with Aditya's
~25 sec Conclusion script.

https://claude.ai/code/session_01TpWxFgZujd5gMFQW5VuSoy
</commit_message>
<xml_diff>
--- a/docs/osint-swarm-architecture.pptx
+++ b/docs/osint-swarm-architecture.pptx
@@ -19,6 +19,7 @@
     <p:sldId id="267" r:id="rId13"/>
     <p:sldId id="268" r:id="rId14"/>
     <p:sldId id="270" r:id="rId21"/>
+    <p:sldId id="271" r:id="rId22"/>
     <p:sldId id="269" r:id="rId15"/>
   </p:sldIdLst>
   <p:notesMasterIdLst>
@@ -9512,6 +9513,1373 @@
 </file>
 
 <file path=ppt/slides/slide14.xml><?xml version="1.0" encoding="utf-8"?>
+<p:sld xmlns:a="http://schemas.openxmlformats.org/drawingml/2006/main" xmlns:p="http://schemas.openxmlformats.org/presentationml/2006/main" xmlns:r="http://schemas.openxmlformats.org/officeDocument/2006/relationships">
+  <p:cSld>
+    <p:bg>
+      <p:bgPr>
+        <a:solidFill>
+          <a:srgbClr val="0F1923"/>
+        </a:solidFill>
+        <a:effectLst/>
+      </p:bgPr>
+    </p:bg>
+    <p:spTree>
+      <p:nvGrpSpPr>
+        <p:cNvPr id="1" name=""/>
+        <p:cNvGrpSpPr/>
+        <p:nvPr/>
+      </p:nvGrpSpPr>
+      <p:grpSpPr/>
+      <p:sp>
+        <p:nvSpPr>
+          <p:cNvPr id="2" name="Rectangle 1"/>
+          <p:cNvSpPr/>
+          <p:nvPr/>
+        </p:nvSpPr>
+        <p:spPr>
+          <a:xfrm>
+            <a:off x="0" y="0"/>
+            <a:ext cx="9144000" cy="54864"/>
+          </a:xfrm>
+          <a:prstGeom prst="rect">
+            <a:avLst/>
+          </a:prstGeom>
+          <a:solidFill>
+            <a:srgbClr val="00B4D8"/>
+          </a:solidFill>
+          <a:ln>
+            <a:noFill/>
+          </a:ln>
+        </p:spPr>
+        <p:style>
+          <a:lnRef idx="1">
+            <a:schemeClr val="accent1"/>
+          </a:lnRef>
+          <a:fillRef idx="3">
+            <a:schemeClr val="accent1"/>
+          </a:fillRef>
+          <a:effectRef idx="2">
+            <a:schemeClr val="accent1"/>
+          </a:effectRef>
+          <a:fontRef idx="minor">
+            <a:schemeClr val="lt1"/>
+          </a:fontRef>
+        </p:style>
+        <p:txBody>
+          <a:bodyPr rtlCol="0" anchor="ctr"/>
+          <a:lstStyle/>
+          <a:p>
+            <a:pPr algn="ctr"/>
+          </a:p>
+        </p:txBody>
+      </p:sp>
+      <p:sp>
+        <p:nvSpPr>
+          <p:cNvPr id="3" name="TextBox 2"/>
+          <p:cNvSpPr txBox="1"/>
+          <p:nvPr/>
+        </p:nvSpPr>
+        <p:spPr>
+          <a:xfrm>
+            <a:off x="640080" y="182880"/>
+            <a:ext cx="7315200" cy="320040"/>
+          </a:xfrm>
+          <a:prstGeom prst="rect">
+            <a:avLst/>
+          </a:prstGeom>
+          <a:noFill/>
+        </p:spPr>
+        <p:txBody>
+          <a:bodyPr wrap="square">
+            <a:spAutoFit/>
+          </a:bodyPr>
+          <a:lstStyle/>
+          <a:p>
+            <a:pPr algn="l"/>
+            <a:r>
+              <a:rPr b="1" sz="1100">
+                <a:solidFill>
+                  <a:srgbClr val="0077B6"/>
+                </a:solidFill>
+              </a:rPr>
+              <a:t>LIMITATIONS  ·  FUTURE WORK</a:t>
+            </a:r>
+          </a:p>
+        </p:txBody>
+      </p:sp>
+      <p:sp>
+        <p:nvSpPr>
+          <p:cNvPr id="4" name="TextBox 3"/>
+          <p:cNvSpPr txBox="1"/>
+          <p:nvPr/>
+        </p:nvSpPr>
+        <p:spPr>
+          <a:xfrm>
+            <a:off x="640080" y="457200"/>
+            <a:ext cx="7863840" cy="411480"/>
+          </a:xfrm>
+          <a:prstGeom prst="rect">
+            <a:avLst/>
+          </a:prstGeom>
+          <a:noFill/>
+        </p:spPr>
+        <p:txBody>
+          <a:bodyPr wrap="square">
+            <a:spAutoFit/>
+          </a:bodyPr>
+          <a:lstStyle/>
+          <a:p>
+            <a:pPr algn="l"/>
+            <a:r>
+              <a:rPr b="1" sz="2200">
+                <a:solidFill>
+                  <a:srgbClr val="FFFFFF"/>
+                </a:solidFill>
+              </a:rPr>
+              <a:t>What we'd change — and where we'd go next.</a:t>
+            </a:r>
+          </a:p>
+        </p:txBody>
+      </p:sp>
+      <p:sp>
+        <p:nvSpPr>
+          <p:cNvPr id="5" name="TextBox 4"/>
+          <p:cNvSpPr txBox="1"/>
+          <p:nvPr/>
+        </p:nvSpPr>
+        <p:spPr>
+          <a:xfrm>
+            <a:off x="457200" y="868680"/>
+            <a:ext cx="4114800" cy="228600"/>
+          </a:xfrm>
+          <a:prstGeom prst="rect">
+            <a:avLst/>
+          </a:prstGeom>
+          <a:noFill/>
+        </p:spPr>
+        <p:txBody>
+          <a:bodyPr wrap="square">
+            <a:spAutoFit/>
+          </a:bodyPr>
+          <a:lstStyle/>
+          <a:p>
+            <a:pPr algn="l"/>
+            <a:r>
+              <a:rPr b="1" sz="900">
+                <a:solidFill>
+                  <a:srgbClr val="00B4D8"/>
+                </a:solidFill>
+              </a:rPr>
+              <a:t>LIMITATIONS</a:t>
+            </a:r>
+          </a:p>
+        </p:txBody>
+      </p:sp>
+      <p:sp>
+        <p:nvSpPr>
+          <p:cNvPr id="6" name="TextBox 5"/>
+          <p:cNvSpPr txBox="1"/>
+          <p:nvPr/>
+        </p:nvSpPr>
+        <p:spPr>
+          <a:xfrm>
+            <a:off x="4846320" y="868680"/>
+            <a:ext cx="4114800" cy="228600"/>
+          </a:xfrm>
+          <a:prstGeom prst="rect">
+            <a:avLst/>
+          </a:prstGeom>
+          <a:noFill/>
+        </p:spPr>
+        <p:txBody>
+          <a:bodyPr wrap="square">
+            <a:spAutoFit/>
+          </a:bodyPr>
+          <a:lstStyle/>
+          <a:p>
+            <a:pPr algn="l"/>
+            <a:r>
+              <a:rPr b="1" sz="900">
+                <a:solidFill>
+                  <a:srgbClr val="00B4D8"/>
+                </a:solidFill>
+              </a:rPr>
+              <a:t>FUTURE WORK</a:t>
+            </a:r>
+          </a:p>
+        </p:txBody>
+      </p:sp>
+      <p:sp>
+        <p:nvSpPr>
+          <p:cNvPr id="7" name="Rectangle 6"/>
+          <p:cNvSpPr/>
+          <p:nvPr/>
+        </p:nvSpPr>
+        <p:spPr>
+          <a:xfrm>
+            <a:off x="457200" y="1143000"/>
+            <a:ext cx="4114800" cy="1097280"/>
+          </a:xfrm>
+          <a:prstGeom prst="rect">
+            <a:avLst/>
+          </a:prstGeom>
+          <a:solidFill>
+            <a:srgbClr val="1E3A52"/>
+          </a:solidFill>
+          <a:ln>
+            <a:noFill/>
+          </a:ln>
+        </p:spPr>
+        <p:style>
+          <a:lnRef idx="1">
+            <a:schemeClr val="accent1"/>
+          </a:lnRef>
+          <a:fillRef idx="3">
+            <a:schemeClr val="accent1"/>
+          </a:fillRef>
+          <a:effectRef idx="2">
+            <a:schemeClr val="accent1"/>
+          </a:effectRef>
+          <a:fontRef idx="minor">
+            <a:schemeClr val="lt1"/>
+          </a:fontRef>
+        </p:style>
+        <p:txBody>
+          <a:bodyPr rtlCol="0" anchor="ctr"/>
+          <a:lstStyle/>
+          <a:p>
+            <a:pPr algn="ctr"/>
+          </a:p>
+        </p:txBody>
+      </p:sp>
+      <p:sp>
+        <p:nvSpPr>
+          <p:cNvPr id="8" name="Rectangle 7"/>
+          <p:cNvSpPr/>
+          <p:nvPr/>
+        </p:nvSpPr>
+        <p:spPr>
+          <a:xfrm>
+            <a:off x="594360" y="1280160"/>
+            <a:ext cx="457200" cy="457200"/>
+          </a:xfrm>
+          <a:prstGeom prst="rect">
+            <a:avLst/>
+          </a:prstGeom>
+          <a:solidFill>
+            <a:srgbClr val="00B4D8"/>
+          </a:solidFill>
+          <a:ln>
+            <a:noFill/>
+          </a:ln>
+        </p:spPr>
+        <p:style>
+          <a:lnRef idx="1">
+            <a:schemeClr val="accent1"/>
+          </a:lnRef>
+          <a:fillRef idx="3">
+            <a:schemeClr val="accent1"/>
+          </a:fillRef>
+          <a:effectRef idx="2">
+            <a:schemeClr val="accent1"/>
+          </a:effectRef>
+          <a:fontRef idx="minor">
+            <a:schemeClr val="lt1"/>
+          </a:fontRef>
+        </p:style>
+        <p:txBody>
+          <a:bodyPr rtlCol="0" anchor="ctr"/>
+          <a:lstStyle/>
+          <a:p>
+            <a:pPr algn="ctr"/>
+          </a:p>
+        </p:txBody>
+      </p:sp>
+      <p:sp>
+        <p:nvSpPr>
+          <p:cNvPr id="9" name="TextBox 8"/>
+          <p:cNvSpPr txBox="1"/>
+          <p:nvPr/>
+        </p:nvSpPr>
+        <p:spPr>
+          <a:xfrm>
+            <a:off x="594360" y="1280160"/>
+            <a:ext cx="457200" cy="457200"/>
+          </a:xfrm>
+          <a:prstGeom prst="rect">
+            <a:avLst/>
+          </a:prstGeom>
+          <a:noFill/>
+        </p:spPr>
+        <p:txBody>
+          <a:bodyPr wrap="square">
+            <a:spAutoFit/>
+          </a:bodyPr>
+          <a:lstStyle/>
+          <a:p>
+            <a:pPr algn="ctr"/>
+            <a:r>
+              <a:rPr b="1" sz="1200">
+                <a:solidFill>
+                  <a:srgbClr val="0F1923"/>
+                </a:solidFill>
+              </a:rPr>
+              <a:t>01</a:t>
+            </a:r>
+          </a:p>
+        </p:txBody>
+      </p:sp>
+      <p:sp>
+        <p:nvSpPr>
+          <p:cNvPr id="10" name="TextBox 9"/>
+          <p:cNvSpPr txBox="1"/>
+          <p:nvPr/>
+        </p:nvSpPr>
+        <p:spPr>
+          <a:xfrm>
+            <a:off x="1143000" y="1234440"/>
+            <a:ext cx="3200400" cy="365760"/>
+          </a:xfrm>
+          <a:prstGeom prst="rect">
+            <a:avLst/>
+          </a:prstGeom>
+          <a:noFill/>
+        </p:spPr>
+        <p:txBody>
+          <a:bodyPr wrap="square">
+            <a:spAutoFit/>
+          </a:bodyPr>
+          <a:lstStyle/>
+          <a:p>
+            <a:pPr algn="l"/>
+            <a:r>
+              <a:rPr b="1" sz="1200">
+                <a:solidFill>
+                  <a:srgbClr val="FFFFFF"/>
+                </a:solidFill>
+              </a:rPr>
+              <a:t>Static data cache</a:t>
+            </a:r>
+          </a:p>
+        </p:txBody>
+      </p:sp>
+      <p:sp>
+        <p:nvSpPr>
+          <p:cNvPr id="11" name="TextBox 10"/>
+          <p:cNvSpPr txBox="1"/>
+          <p:nvPr/>
+        </p:nvSpPr>
+        <p:spPr>
+          <a:xfrm>
+            <a:off x="1143000" y="1600200"/>
+            <a:ext cx="3200400" cy="548640"/>
+          </a:xfrm>
+          <a:prstGeom prst="rect">
+            <a:avLst/>
+          </a:prstGeom>
+          <a:noFill/>
+        </p:spPr>
+        <p:txBody>
+          <a:bodyPr wrap="square">
+            <a:spAutoFit/>
+          </a:bodyPr>
+          <a:lstStyle/>
+          <a:p>
+            <a:pPr algn="l"/>
+            <a:r>
+              <a:rPr b="0" sz="1000">
+                <a:solidFill>
+                  <a:srgbClr val="CBD5E1"/>
+                </a:solidFill>
+              </a:rPr>
+              <a:t>Evidence reflects the last pull date. OFAC, court records, and GDELT go stale without a manual refresh.</a:t>
+            </a:r>
+          </a:p>
+        </p:txBody>
+      </p:sp>
+      <p:sp>
+        <p:nvSpPr>
+          <p:cNvPr id="12" name="Rectangle 11"/>
+          <p:cNvSpPr/>
+          <p:nvPr/>
+        </p:nvSpPr>
+        <p:spPr>
+          <a:xfrm>
+            <a:off x="457200" y="2377440"/>
+            <a:ext cx="4114800" cy="1097280"/>
+          </a:xfrm>
+          <a:prstGeom prst="rect">
+            <a:avLst/>
+          </a:prstGeom>
+          <a:solidFill>
+            <a:srgbClr val="1E3A52"/>
+          </a:solidFill>
+          <a:ln>
+            <a:noFill/>
+          </a:ln>
+        </p:spPr>
+        <p:style>
+          <a:lnRef idx="1">
+            <a:schemeClr val="accent1"/>
+          </a:lnRef>
+          <a:fillRef idx="3">
+            <a:schemeClr val="accent1"/>
+          </a:fillRef>
+          <a:effectRef idx="2">
+            <a:schemeClr val="accent1"/>
+          </a:effectRef>
+          <a:fontRef idx="minor">
+            <a:schemeClr val="lt1"/>
+          </a:fontRef>
+        </p:style>
+        <p:txBody>
+          <a:bodyPr rtlCol="0" anchor="ctr"/>
+          <a:lstStyle/>
+          <a:p>
+            <a:pPr algn="ctr"/>
+          </a:p>
+        </p:txBody>
+      </p:sp>
+      <p:sp>
+        <p:nvSpPr>
+          <p:cNvPr id="13" name="Rectangle 12"/>
+          <p:cNvSpPr/>
+          <p:nvPr/>
+        </p:nvSpPr>
+        <p:spPr>
+          <a:xfrm>
+            <a:off x="594360" y="2514600"/>
+            <a:ext cx="457200" cy="457200"/>
+          </a:xfrm>
+          <a:prstGeom prst="rect">
+            <a:avLst/>
+          </a:prstGeom>
+          <a:solidFill>
+            <a:srgbClr val="00B4D8"/>
+          </a:solidFill>
+          <a:ln>
+            <a:noFill/>
+          </a:ln>
+        </p:spPr>
+        <p:style>
+          <a:lnRef idx="1">
+            <a:schemeClr val="accent1"/>
+          </a:lnRef>
+          <a:fillRef idx="3">
+            <a:schemeClr val="accent1"/>
+          </a:fillRef>
+          <a:effectRef idx="2">
+            <a:schemeClr val="accent1"/>
+          </a:effectRef>
+          <a:fontRef idx="minor">
+            <a:schemeClr val="lt1"/>
+          </a:fontRef>
+        </p:style>
+        <p:txBody>
+          <a:bodyPr rtlCol="0" anchor="ctr"/>
+          <a:lstStyle/>
+          <a:p>
+            <a:pPr algn="ctr"/>
+          </a:p>
+        </p:txBody>
+      </p:sp>
+      <p:sp>
+        <p:nvSpPr>
+          <p:cNvPr id="14" name="TextBox 13"/>
+          <p:cNvSpPr txBox="1"/>
+          <p:nvPr/>
+        </p:nvSpPr>
+        <p:spPr>
+          <a:xfrm>
+            <a:off x="594360" y="2514600"/>
+            <a:ext cx="457200" cy="457200"/>
+          </a:xfrm>
+          <a:prstGeom prst="rect">
+            <a:avLst/>
+          </a:prstGeom>
+          <a:noFill/>
+        </p:spPr>
+        <p:txBody>
+          <a:bodyPr wrap="square">
+            <a:spAutoFit/>
+          </a:bodyPr>
+          <a:lstStyle/>
+          <a:p>
+            <a:pPr algn="ctr"/>
+            <a:r>
+              <a:rPr b="1" sz="1200">
+                <a:solidFill>
+                  <a:srgbClr val="0F1923"/>
+                </a:solidFill>
+              </a:rPr>
+              <a:t>02</a:t>
+            </a:r>
+          </a:p>
+        </p:txBody>
+      </p:sp>
+      <p:sp>
+        <p:nvSpPr>
+          <p:cNvPr id="15" name="TextBox 14"/>
+          <p:cNvSpPr txBox="1"/>
+          <p:nvPr/>
+        </p:nvSpPr>
+        <p:spPr>
+          <a:xfrm>
+            <a:off x="1143000" y="2468880"/>
+            <a:ext cx="3200400" cy="365760"/>
+          </a:xfrm>
+          <a:prstGeom prst="rect">
+            <a:avLst/>
+          </a:prstGeom>
+          <a:noFill/>
+        </p:spPr>
+        <p:txBody>
+          <a:bodyPr wrap="square">
+            <a:spAutoFit/>
+          </a:bodyPr>
+          <a:lstStyle/>
+          <a:p>
+            <a:pPr algn="l"/>
+            <a:r>
+              <a:rPr b="1" sz="1200">
+                <a:solidFill>
+                  <a:srgbClr val="FFFFFF"/>
+                </a:solidFill>
+              </a:rPr>
+              <a:t>English-only news signal</a:t>
+            </a:r>
+          </a:p>
+        </p:txBody>
+      </p:sp>
+      <p:sp>
+        <p:nvSpPr>
+          <p:cNvPr id="16" name="TextBox 15"/>
+          <p:cNvSpPr txBox="1"/>
+          <p:nvPr/>
+        </p:nvSpPr>
+        <p:spPr>
+          <a:xfrm>
+            <a:off x="1143000" y="2834640"/>
+            <a:ext cx="3200400" cy="548640"/>
+          </a:xfrm>
+          <a:prstGeom prst="rect">
+            <a:avLst/>
+          </a:prstGeom>
+          <a:noFill/>
+        </p:spPr>
+        <p:txBody>
+          <a:bodyPr wrap="square">
+            <a:spAutoFit/>
+          </a:bodyPr>
+          <a:lstStyle/>
+          <a:p>
+            <a:pPr algn="l"/>
+            <a:r>
+              <a:rPr b="0" sz="1000">
+                <a:solidFill>
+                  <a:srgbClr val="CBD5E1"/>
+                </a:solidFill>
+              </a:rPr>
+              <a:t>GDELT is filtered to English articles only. International adverse media in other languages is not captured.</a:t>
+            </a:r>
+          </a:p>
+        </p:txBody>
+      </p:sp>
+      <p:sp>
+        <p:nvSpPr>
+          <p:cNvPr id="17" name="Rectangle 16"/>
+          <p:cNvSpPr/>
+          <p:nvPr/>
+        </p:nvSpPr>
+        <p:spPr>
+          <a:xfrm>
+            <a:off x="457200" y="3611880"/>
+            <a:ext cx="4114800" cy="1097280"/>
+          </a:xfrm>
+          <a:prstGeom prst="rect">
+            <a:avLst/>
+          </a:prstGeom>
+          <a:solidFill>
+            <a:srgbClr val="1E3A52"/>
+          </a:solidFill>
+          <a:ln>
+            <a:noFill/>
+          </a:ln>
+        </p:spPr>
+        <p:style>
+          <a:lnRef idx="1">
+            <a:schemeClr val="accent1"/>
+          </a:lnRef>
+          <a:fillRef idx="3">
+            <a:schemeClr val="accent1"/>
+          </a:fillRef>
+          <a:effectRef idx="2">
+            <a:schemeClr val="accent1"/>
+          </a:effectRef>
+          <a:fontRef idx="minor">
+            <a:schemeClr val="lt1"/>
+          </a:fontRef>
+        </p:style>
+        <p:txBody>
+          <a:bodyPr rtlCol="0" anchor="ctr"/>
+          <a:lstStyle/>
+          <a:p>
+            <a:pPr algn="ctr"/>
+          </a:p>
+        </p:txBody>
+      </p:sp>
+      <p:sp>
+        <p:nvSpPr>
+          <p:cNvPr id="18" name="Rectangle 17"/>
+          <p:cNvSpPr/>
+          <p:nvPr/>
+        </p:nvSpPr>
+        <p:spPr>
+          <a:xfrm>
+            <a:off x="594360" y="3749040"/>
+            <a:ext cx="457200" cy="457200"/>
+          </a:xfrm>
+          <a:prstGeom prst="rect">
+            <a:avLst/>
+          </a:prstGeom>
+          <a:solidFill>
+            <a:srgbClr val="00B4D8"/>
+          </a:solidFill>
+          <a:ln>
+            <a:noFill/>
+          </a:ln>
+        </p:spPr>
+        <p:style>
+          <a:lnRef idx="1">
+            <a:schemeClr val="accent1"/>
+          </a:lnRef>
+          <a:fillRef idx="3">
+            <a:schemeClr val="accent1"/>
+          </a:fillRef>
+          <a:effectRef idx="2">
+            <a:schemeClr val="accent1"/>
+          </a:effectRef>
+          <a:fontRef idx="minor">
+            <a:schemeClr val="lt1"/>
+          </a:fontRef>
+        </p:style>
+        <p:txBody>
+          <a:bodyPr rtlCol="0" anchor="ctr"/>
+          <a:lstStyle/>
+          <a:p>
+            <a:pPr algn="ctr"/>
+          </a:p>
+        </p:txBody>
+      </p:sp>
+      <p:sp>
+        <p:nvSpPr>
+          <p:cNvPr id="19" name="TextBox 18"/>
+          <p:cNvSpPr txBox="1"/>
+          <p:nvPr/>
+        </p:nvSpPr>
+        <p:spPr>
+          <a:xfrm>
+            <a:off x="594360" y="3749040"/>
+            <a:ext cx="457200" cy="457200"/>
+          </a:xfrm>
+          <a:prstGeom prst="rect">
+            <a:avLst/>
+          </a:prstGeom>
+          <a:noFill/>
+        </p:spPr>
+        <p:txBody>
+          <a:bodyPr wrap="square">
+            <a:spAutoFit/>
+          </a:bodyPr>
+          <a:lstStyle/>
+          <a:p>
+            <a:pPr algn="ctr"/>
+            <a:r>
+              <a:rPr b="1" sz="1200">
+                <a:solidFill>
+                  <a:srgbClr val="0F1923"/>
+                </a:solidFill>
+              </a:rPr>
+              <a:t>03</a:t>
+            </a:r>
+          </a:p>
+        </p:txBody>
+      </p:sp>
+      <p:sp>
+        <p:nvSpPr>
+          <p:cNvPr id="20" name="TextBox 19"/>
+          <p:cNvSpPr txBox="1"/>
+          <p:nvPr/>
+        </p:nvSpPr>
+        <p:spPr>
+          <a:xfrm>
+            <a:off x="1143000" y="3703320"/>
+            <a:ext cx="3200400" cy="365760"/>
+          </a:xfrm>
+          <a:prstGeom prst="rect">
+            <a:avLst/>
+          </a:prstGeom>
+          <a:noFill/>
+        </p:spPr>
+        <p:txBody>
+          <a:bodyPr wrap="square">
+            <a:spAutoFit/>
+          </a:bodyPr>
+          <a:lstStyle/>
+          <a:p>
+            <a:pPr algn="l"/>
+            <a:r>
+              <a:rPr b="1" sz="1200">
+                <a:solidFill>
+                  <a:srgbClr val="FFFFFF"/>
+                </a:solidFill>
+              </a:rPr>
+              <a:t>Narrative not formally verified</a:t>
+            </a:r>
+          </a:p>
+        </p:txBody>
+      </p:sp>
+      <p:sp>
+        <p:nvSpPr>
+          <p:cNvPr id="21" name="TextBox 20"/>
+          <p:cNvSpPr txBox="1"/>
+          <p:nvPr/>
+        </p:nvSpPr>
+        <p:spPr>
+          <a:xfrm>
+            <a:off x="1143000" y="4069080"/>
+            <a:ext cx="3200400" cy="548640"/>
+          </a:xfrm>
+          <a:prstGeom prst="rect">
+            <a:avLst/>
+          </a:prstGeom>
+          <a:noFill/>
+        </p:spPr>
+        <p:txBody>
+          <a:bodyPr wrap="square">
+            <a:spAutoFit/>
+          </a:bodyPr>
+          <a:lstStyle/>
+          <a:p>
+            <a:pPr algn="l"/>
+            <a:r>
+              <a:rPr b="0" sz="1000">
+                <a:solidFill>
+                  <a:srgbClr val="CBD5E1"/>
+                </a:solidFill>
+              </a:rPr>
+              <a:t>The LLM narrative is contract-bound but not sentence-level cross-checked against individual evidence rows.</a:t>
+            </a:r>
+          </a:p>
+        </p:txBody>
+      </p:sp>
+      <p:sp>
+        <p:nvSpPr>
+          <p:cNvPr id="22" name="Rectangle 21"/>
+          <p:cNvSpPr/>
+          <p:nvPr/>
+        </p:nvSpPr>
+        <p:spPr>
+          <a:xfrm>
+            <a:off x="4846320" y="1143000"/>
+            <a:ext cx="4114800" cy="1097280"/>
+          </a:xfrm>
+          <a:prstGeom prst="rect">
+            <a:avLst/>
+          </a:prstGeom>
+          <a:solidFill>
+            <a:srgbClr val="1E3A52"/>
+          </a:solidFill>
+          <a:ln>
+            <a:noFill/>
+          </a:ln>
+        </p:spPr>
+        <p:style>
+          <a:lnRef idx="1">
+            <a:schemeClr val="accent1"/>
+          </a:lnRef>
+          <a:fillRef idx="3">
+            <a:schemeClr val="accent1"/>
+          </a:fillRef>
+          <a:effectRef idx="2">
+            <a:schemeClr val="accent1"/>
+          </a:effectRef>
+          <a:fontRef idx="minor">
+            <a:schemeClr val="lt1"/>
+          </a:fontRef>
+        </p:style>
+        <p:txBody>
+          <a:bodyPr rtlCol="0" anchor="ctr"/>
+          <a:lstStyle/>
+          <a:p>
+            <a:pPr algn="ctr"/>
+          </a:p>
+        </p:txBody>
+      </p:sp>
+      <p:sp>
+        <p:nvSpPr>
+          <p:cNvPr id="23" name="Rectangle 22"/>
+          <p:cNvSpPr/>
+          <p:nvPr/>
+        </p:nvSpPr>
+        <p:spPr>
+          <a:xfrm>
+            <a:off x="4983480" y="1280160"/>
+            <a:ext cx="457200" cy="457200"/>
+          </a:xfrm>
+          <a:prstGeom prst="rect">
+            <a:avLst/>
+          </a:prstGeom>
+          <a:solidFill>
+            <a:srgbClr val="00B4D8"/>
+          </a:solidFill>
+          <a:ln>
+            <a:noFill/>
+          </a:ln>
+        </p:spPr>
+        <p:style>
+          <a:lnRef idx="1">
+            <a:schemeClr val="accent1"/>
+          </a:lnRef>
+          <a:fillRef idx="3">
+            <a:schemeClr val="accent1"/>
+          </a:fillRef>
+          <a:effectRef idx="2">
+            <a:schemeClr val="accent1"/>
+          </a:effectRef>
+          <a:fontRef idx="minor">
+            <a:schemeClr val="lt1"/>
+          </a:fontRef>
+        </p:style>
+        <p:txBody>
+          <a:bodyPr rtlCol="0" anchor="ctr"/>
+          <a:lstStyle/>
+          <a:p>
+            <a:pPr algn="ctr"/>
+          </a:p>
+        </p:txBody>
+      </p:sp>
+      <p:sp>
+        <p:nvSpPr>
+          <p:cNvPr id="24" name="TextBox 23"/>
+          <p:cNvSpPr txBox="1"/>
+          <p:nvPr/>
+        </p:nvSpPr>
+        <p:spPr>
+          <a:xfrm>
+            <a:off x="4983480" y="1280160"/>
+            <a:ext cx="457200" cy="457200"/>
+          </a:xfrm>
+          <a:prstGeom prst="rect">
+            <a:avLst/>
+          </a:prstGeom>
+          <a:noFill/>
+        </p:spPr>
+        <p:txBody>
+          <a:bodyPr wrap="square">
+            <a:spAutoFit/>
+          </a:bodyPr>
+          <a:lstStyle/>
+          <a:p>
+            <a:pPr algn="ctr"/>
+            <a:r>
+              <a:rPr b="1" sz="1200">
+                <a:solidFill>
+                  <a:srgbClr val="0F1923"/>
+                </a:solidFill>
+              </a:rPr>
+              <a:t>04</a:t>
+            </a:r>
+          </a:p>
+        </p:txBody>
+      </p:sp>
+      <p:sp>
+        <p:nvSpPr>
+          <p:cNvPr id="25" name="TextBox 24"/>
+          <p:cNvSpPr txBox="1"/>
+          <p:nvPr/>
+        </p:nvSpPr>
+        <p:spPr>
+          <a:xfrm>
+            <a:off x="5532120" y="1234440"/>
+            <a:ext cx="3200400" cy="365760"/>
+          </a:xfrm>
+          <a:prstGeom prst="rect">
+            <a:avLst/>
+          </a:prstGeom>
+          <a:noFill/>
+        </p:spPr>
+        <p:txBody>
+          <a:bodyPr wrap="square">
+            <a:spAutoFit/>
+          </a:bodyPr>
+          <a:lstStyle/>
+          <a:p>
+            <a:pPr algn="l"/>
+            <a:r>
+              <a:rPr b="1" sz="1200">
+                <a:solidFill>
+                  <a:srgbClr val="FFFFFF"/>
+                </a:solidFill>
+              </a:rPr>
+              <a:t>Scheduled data refresh</a:t>
+            </a:r>
+          </a:p>
+        </p:txBody>
+      </p:sp>
+      <p:sp>
+        <p:nvSpPr>
+          <p:cNvPr id="26" name="TextBox 25"/>
+          <p:cNvSpPr txBox="1"/>
+          <p:nvPr/>
+        </p:nvSpPr>
+        <p:spPr>
+          <a:xfrm>
+            <a:off x="5532120" y="1600200"/>
+            <a:ext cx="3200400" cy="548640"/>
+          </a:xfrm>
+          <a:prstGeom prst="rect">
+            <a:avLst/>
+          </a:prstGeom>
+          <a:noFill/>
+        </p:spPr>
+        <p:txBody>
+          <a:bodyPr wrap="square">
+            <a:spAutoFit/>
+          </a:bodyPr>
+          <a:lstStyle/>
+          <a:p>
+            <a:pPr algn="l"/>
+            <a:r>
+              <a:rPr b="0" sz="1000">
+                <a:solidFill>
+                  <a:srgbClr val="CBD5E1"/>
+                </a:solidFill>
+              </a:rPr>
+              <a:t>Automate nightly pulls for all four sources so every investigation reflects the current day's data.</a:t>
+            </a:r>
+          </a:p>
+        </p:txBody>
+      </p:sp>
+      <p:sp>
+        <p:nvSpPr>
+          <p:cNvPr id="27" name="Rectangle 26"/>
+          <p:cNvSpPr/>
+          <p:nvPr/>
+        </p:nvSpPr>
+        <p:spPr>
+          <a:xfrm>
+            <a:off x="4846320" y="2377440"/>
+            <a:ext cx="4114800" cy="1097280"/>
+          </a:xfrm>
+          <a:prstGeom prst="rect">
+            <a:avLst/>
+          </a:prstGeom>
+          <a:solidFill>
+            <a:srgbClr val="1E3A52"/>
+          </a:solidFill>
+          <a:ln>
+            <a:noFill/>
+          </a:ln>
+        </p:spPr>
+        <p:style>
+          <a:lnRef idx="1">
+            <a:schemeClr val="accent1"/>
+          </a:lnRef>
+          <a:fillRef idx="3">
+            <a:schemeClr val="accent1"/>
+          </a:fillRef>
+          <a:effectRef idx="2">
+            <a:schemeClr val="accent1"/>
+          </a:effectRef>
+          <a:fontRef idx="minor">
+            <a:schemeClr val="lt1"/>
+          </a:fontRef>
+        </p:style>
+        <p:txBody>
+          <a:bodyPr rtlCol="0" anchor="ctr"/>
+          <a:lstStyle/>
+          <a:p>
+            <a:pPr algn="ctr"/>
+          </a:p>
+        </p:txBody>
+      </p:sp>
+      <p:sp>
+        <p:nvSpPr>
+          <p:cNvPr id="28" name="Rectangle 27"/>
+          <p:cNvSpPr/>
+          <p:nvPr/>
+        </p:nvSpPr>
+        <p:spPr>
+          <a:xfrm>
+            <a:off x="4983480" y="2514600"/>
+            <a:ext cx="457200" cy="457200"/>
+          </a:xfrm>
+          <a:prstGeom prst="rect">
+            <a:avLst/>
+          </a:prstGeom>
+          <a:solidFill>
+            <a:srgbClr val="00B4D8"/>
+          </a:solidFill>
+          <a:ln>
+            <a:noFill/>
+          </a:ln>
+        </p:spPr>
+        <p:style>
+          <a:lnRef idx="1">
+            <a:schemeClr val="accent1"/>
+          </a:lnRef>
+          <a:fillRef idx="3">
+            <a:schemeClr val="accent1"/>
+          </a:fillRef>
+          <a:effectRef idx="2">
+            <a:schemeClr val="accent1"/>
+          </a:effectRef>
+          <a:fontRef idx="minor">
+            <a:schemeClr val="lt1"/>
+          </a:fontRef>
+        </p:style>
+        <p:txBody>
+          <a:bodyPr rtlCol="0" anchor="ctr"/>
+          <a:lstStyle/>
+          <a:p>
+            <a:pPr algn="ctr"/>
+          </a:p>
+        </p:txBody>
+      </p:sp>
+      <p:sp>
+        <p:nvSpPr>
+          <p:cNvPr id="29" name="TextBox 28"/>
+          <p:cNvSpPr txBox="1"/>
+          <p:nvPr/>
+        </p:nvSpPr>
+        <p:spPr>
+          <a:xfrm>
+            <a:off x="4983480" y="2514600"/>
+            <a:ext cx="457200" cy="457200"/>
+          </a:xfrm>
+          <a:prstGeom prst="rect">
+            <a:avLst/>
+          </a:prstGeom>
+          <a:noFill/>
+        </p:spPr>
+        <p:txBody>
+          <a:bodyPr wrap="square">
+            <a:spAutoFit/>
+          </a:bodyPr>
+          <a:lstStyle/>
+          <a:p>
+            <a:pPr algn="ctr"/>
+            <a:r>
+              <a:rPr b="1" sz="1200">
+                <a:solidFill>
+                  <a:srgbClr val="0F1923"/>
+                </a:solidFill>
+              </a:rPr>
+              <a:t>05</a:t>
+            </a:r>
+          </a:p>
+        </p:txBody>
+      </p:sp>
+      <p:sp>
+        <p:nvSpPr>
+          <p:cNvPr id="30" name="TextBox 29"/>
+          <p:cNvSpPr txBox="1"/>
+          <p:nvPr/>
+        </p:nvSpPr>
+        <p:spPr>
+          <a:xfrm>
+            <a:off x="5532120" y="2468880"/>
+            <a:ext cx="3200400" cy="365760"/>
+          </a:xfrm>
+          <a:prstGeom prst="rect">
+            <a:avLst/>
+          </a:prstGeom>
+          <a:noFill/>
+        </p:spPr>
+        <p:txBody>
+          <a:bodyPr wrap="square">
+            <a:spAutoFit/>
+          </a:bodyPr>
+          <a:lstStyle/>
+          <a:p>
+            <a:pPr algn="l"/>
+            <a:r>
+              <a:rPr b="1" sz="1200">
+                <a:solidFill>
+                  <a:srgbClr val="FFFFFF"/>
+                </a:solidFill>
+              </a:rPr>
+              <a:t>On-demand entity coverage</a:t>
+            </a:r>
+          </a:p>
+        </p:txBody>
+      </p:sp>
+      <p:sp>
+        <p:nvSpPr>
+          <p:cNvPr id="31" name="TextBox 30"/>
+          <p:cNvSpPr txBox="1"/>
+          <p:nvPr/>
+        </p:nvSpPr>
+        <p:spPr>
+          <a:xfrm>
+            <a:off x="5532120" y="2834640"/>
+            <a:ext cx="3200400" cy="548640"/>
+          </a:xfrm>
+          <a:prstGeom prst="rect">
+            <a:avLst/>
+          </a:prstGeom>
+          <a:noFill/>
+        </p:spPr>
+        <p:txBody>
+          <a:bodyPr wrap="square">
+            <a:spAutoFit/>
+          </a:bodyPr>
+          <a:lstStyle/>
+          <a:p>
+            <a:pPr algn="l"/>
+            <a:r>
+              <a:rPr b="0" sz="1000">
+                <a:solidFill>
+                  <a:srgbClr val="CBD5E1"/>
+                </a:solidFill>
+              </a:rPr>
+              <a:t>Resolve and pull any public company at query time via SEC EDGAR, removing the five-entity cache limit.</a:t>
+            </a:r>
+          </a:p>
+        </p:txBody>
+      </p:sp>
+      <p:sp>
+        <p:nvSpPr>
+          <p:cNvPr id="32" name="Rectangle 31"/>
+          <p:cNvSpPr/>
+          <p:nvPr/>
+        </p:nvSpPr>
+        <p:spPr>
+          <a:xfrm>
+            <a:off x="4846320" y="3611880"/>
+            <a:ext cx="4114800" cy="1097280"/>
+          </a:xfrm>
+          <a:prstGeom prst="rect">
+            <a:avLst/>
+          </a:prstGeom>
+          <a:solidFill>
+            <a:srgbClr val="1E3A52"/>
+          </a:solidFill>
+          <a:ln>
+            <a:noFill/>
+          </a:ln>
+        </p:spPr>
+        <p:style>
+          <a:lnRef idx="1">
+            <a:schemeClr val="accent1"/>
+          </a:lnRef>
+          <a:fillRef idx="3">
+            <a:schemeClr val="accent1"/>
+          </a:fillRef>
+          <a:effectRef idx="2">
+            <a:schemeClr val="accent1"/>
+          </a:effectRef>
+          <a:fontRef idx="minor">
+            <a:schemeClr val="lt1"/>
+          </a:fontRef>
+        </p:style>
+        <p:txBody>
+          <a:bodyPr rtlCol="0" anchor="ctr"/>
+          <a:lstStyle/>
+          <a:p>
+            <a:pPr algn="ctr"/>
+          </a:p>
+        </p:txBody>
+      </p:sp>
+      <p:sp>
+        <p:nvSpPr>
+          <p:cNvPr id="33" name="Rectangle 32"/>
+          <p:cNvSpPr/>
+          <p:nvPr/>
+        </p:nvSpPr>
+        <p:spPr>
+          <a:xfrm>
+            <a:off x="4983480" y="3749040"/>
+            <a:ext cx="457200" cy="457200"/>
+          </a:xfrm>
+          <a:prstGeom prst="rect">
+            <a:avLst/>
+          </a:prstGeom>
+          <a:solidFill>
+            <a:srgbClr val="00B4D8"/>
+          </a:solidFill>
+          <a:ln>
+            <a:noFill/>
+          </a:ln>
+        </p:spPr>
+        <p:style>
+          <a:lnRef idx="1">
+            <a:schemeClr val="accent1"/>
+          </a:lnRef>
+          <a:fillRef idx="3">
+            <a:schemeClr val="accent1"/>
+          </a:fillRef>
+          <a:effectRef idx="2">
+            <a:schemeClr val="accent1"/>
+          </a:effectRef>
+          <a:fontRef idx="minor">
+            <a:schemeClr val="lt1"/>
+          </a:fontRef>
+        </p:style>
+        <p:txBody>
+          <a:bodyPr rtlCol="0" anchor="ctr"/>
+          <a:lstStyle/>
+          <a:p>
+            <a:pPr algn="ctr"/>
+          </a:p>
+        </p:txBody>
+      </p:sp>
+      <p:sp>
+        <p:nvSpPr>
+          <p:cNvPr id="34" name="TextBox 33"/>
+          <p:cNvSpPr txBox="1"/>
+          <p:nvPr/>
+        </p:nvSpPr>
+        <p:spPr>
+          <a:xfrm>
+            <a:off x="4983480" y="3749040"/>
+            <a:ext cx="457200" cy="457200"/>
+          </a:xfrm>
+          <a:prstGeom prst="rect">
+            <a:avLst/>
+          </a:prstGeom>
+          <a:noFill/>
+        </p:spPr>
+        <p:txBody>
+          <a:bodyPr wrap="square">
+            <a:spAutoFit/>
+          </a:bodyPr>
+          <a:lstStyle/>
+          <a:p>
+            <a:pPr algn="ctr"/>
+            <a:r>
+              <a:rPr b="1" sz="1200">
+                <a:solidFill>
+                  <a:srgbClr val="0F1923"/>
+                </a:solidFill>
+              </a:rPr>
+              <a:t>06</a:t>
+            </a:r>
+          </a:p>
+        </p:txBody>
+      </p:sp>
+      <p:sp>
+        <p:nvSpPr>
+          <p:cNvPr id="35" name="TextBox 34"/>
+          <p:cNvSpPr txBox="1"/>
+          <p:nvPr/>
+        </p:nvSpPr>
+        <p:spPr>
+          <a:xfrm>
+            <a:off x="5532120" y="3703320"/>
+            <a:ext cx="3200400" cy="365760"/>
+          </a:xfrm>
+          <a:prstGeom prst="rect">
+            <a:avLst/>
+          </a:prstGeom>
+          <a:noFill/>
+        </p:spPr>
+        <p:txBody>
+          <a:bodyPr wrap="square">
+            <a:spAutoFit/>
+          </a:bodyPr>
+          <a:lstStyle/>
+          <a:p>
+            <a:pPr algn="l"/>
+            <a:r>
+              <a:rPr b="1" sz="1200">
+                <a:solidFill>
+                  <a:srgbClr val="FFFFFF"/>
+                </a:solidFill>
+              </a:rPr>
+              <a:t>Private source integration</a:t>
+            </a:r>
+          </a:p>
+        </p:txBody>
+      </p:sp>
+      <p:sp>
+        <p:nvSpPr>
+          <p:cNvPr id="36" name="TextBox 35"/>
+          <p:cNvSpPr txBox="1"/>
+          <p:nvPr/>
+        </p:nvSpPr>
+        <p:spPr>
+          <a:xfrm>
+            <a:off x="5532120" y="4069080"/>
+            <a:ext cx="3200400" cy="548640"/>
+          </a:xfrm>
+          <a:prstGeom prst="rect">
+            <a:avLst/>
+          </a:prstGeom>
+          <a:noFill/>
+        </p:spPr>
+        <p:txBody>
+          <a:bodyPr wrap="square">
+            <a:spAutoFit/>
+          </a:bodyPr>
+          <a:lstStyle/>
+          <a:p>
+            <a:pPr algn="l"/>
+            <a:r>
+              <a:rPr b="0" sz="1000">
+                <a:solidFill>
+                  <a:srgbClr val="CBD5E1"/>
+                </a:solidFill>
+              </a:rPr>
+              <a:t>Add licensed data (OpenCorporates, Dun &amp; Bradstreet) to support non-public and international entities.</a:t>
+            </a:r>
+          </a:p>
+        </p:txBody>
+      </p:sp>
+      <p:sp>
+        <p:nvSpPr>
+          <p:cNvPr id="37" name="TextBox 36"/>
+          <p:cNvSpPr txBox="1"/>
+          <p:nvPr/>
+        </p:nvSpPr>
+        <p:spPr>
+          <a:xfrm>
+            <a:off x="8229600" y="4709160"/>
+            <a:ext cx="640080" cy="274320"/>
+          </a:xfrm>
+          <a:prstGeom prst="rect">
+            <a:avLst/>
+          </a:prstGeom>
+          <a:noFill/>
+        </p:spPr>
+        <p:txBody>
+          <a:bodyPr wrap="square">
+            <a:spAutoFit/>
+          </a:bodyPr>
+          <a:lstStyle/>
+          <a:p>
+            <a:pPr algn="r"/>
+            <a:r>
+              <a:rPr b="0" sz="1000">
+                <a:solidFill>
+                  <a:srgbClr val="64748B"/>
+                </a:solidFill>
+              </a:rPr>
+              <a:t>14</a:t>
+            </a:r>
+          </a:p>
+        </p:txBody>
+      </p:sp>
+    </p:spTree>
+  </p:cSld>
+  <p:clrMapOvr>
+    <a:masterClrMapping/>
+  </p:clrMapOvr>
+</p:sld>
+</file>
+
+<file path=ppt/slides/slide15.xml><?xml version="1.0" encoding="utf-8"?>
 <p:sld xmlns:a="http://schemas.openxmlformats.org/drawingml/2006/main" xmlns:r="http://schemas.openxmlformats.org/officeDocument/2006/relationships" xmlns:p="http://schemas.openxmlformats.org/presentationml/2006/main">
   <p:cSld name="Slide 14">
     <p:bg>
@@ -10639,7 +12007,7 @@
 </p:sld>
 </file>
 
-<file path=ppt/slides/slide15.xml><?xml version="1.0" encoding="utf-8"?>
+<file path=ppt/slides/slide16.xml><?xml version="1.0" encoding="utf-8"?>
 <p:sld xmlns:a="http://schemas.openxmlformats.org/drawingml/2006/main" xmlns:p="http://schemas.openxmlformats.org/presentationml/2006/main" xmlns:r="http://schemas.openxmlformats.org/officeDocument/2006/relationships">
   <p:cSld>
     <p:bg>
@@ -10709,7 +12077,7 @@
         <p:spPr>
           <a:xfrm>
             <a:off x="640080" y="182880"/>
-            <a:ext cx="7315200" cy="320040"/>
+            <a:ext cx="4572000" cy="320040"/>
           </a:xfrm>
           <a:prstGeom prst="rect">
             <a:avLst/>
@@ -10729,7 +12097,7 @@
                   <a:srgbClr val="0077B6"/>
                 </a:solidFill>
               </a:rPr>
-              <a:t>LIMITATIONS  ·  FUTURE WORK</a:t>
+              <a:t>CONCLUSION</a:t>
             </a:r>
           </a:p>
         </p:txBody>
@@ -10763,89 +12131,21 @@
                   <a:srgbClr val="FFFFFF"/>
                 </a:solidFill>
               </a:rPr>
-              <a:t>What we'd change — and where we'd go next.</a:t>
-            </a:r>
-          </a:p>
-        </p:txBody>
-      </p:sp>
-      <p:sp>
-        <p:nvSpPr>
-          <p:cNvPr id="5" name="TextBox 4"/>
-          <p:cNvSpPr txBox="1"/>
-          <p:nvPr/>
-        </p:nvSpPr>
-        <p:spPr>
-          <a:xfrm>
-            <a:off x="457200" y="868680"/>
-            <a:ext cx="4114800" cy="228600"/>
-          </a:xfrm>
-          <a:prstGeom prst="rect">
-            <a:avLst/>
-          </a:prstGeom>
-          <a:noFill/>
-        </p:spPr>
-        <p:txBody>
-          <a:bodyPr wrap="square">
-            <a:spAutoFit/>
-          </a:bodyPr>
-          <a:lstStyle/>
-          <a:p>
-            <a:pPr algn="l"/>
-            <a:r>
-              <a:rPr b="1" sz="900">
-                <a:solidFill>
-                  <a:srgbClr val="00B4D8"/>
-                </a:solidFill>
-              </a:rPr>
-              <a:t>LIMITATIONS</a:t>
-            </a:r>
-          </a:p>
-        </p:txBody>
-      </p:sp>
-      <p:sp>
-        <p:nvSpPr>
-          <p:cNvPr id="6" name="TextBox 5"/>
-          <p:cNvSpPr txBox="1"/>
-          <p:nvPr/>
-        </p:nvSpPr>
-        <p:spPr>
-          <a:xfrm>
-            <a:off x="4846320" y="868680"/>
-            <a:ext cx="4114800" cy="228600"/>
-          </a:xfrm>
-          <a:prstGeom prst="rect">
-            <a:avLst/>
-          </a:prstGeom>
-          <a:noFill/>
-        </p:spPr>
-        <p:txBody>
-          <a:bodyPr wrap="square">
-            <a:spAutoFit/>
-          </a:bodyPr>
-          <a:lstStyle/>
-          <a:p>
-            <a:pPr algn="l"/>
-            <a:r>
-              <a:rPr b="1" sz="900">
-                <a:solidFill>
-                  <a:srgbClr val="00B4D8"/>
-                </a:solidFill>
-              </a:rPr>
-              <a:t>FUTURE WORK</a:t>
-            </a:r>
-          </a:p>
-        </p:txBody>
-      </p:sp>
-      <p:sp>
-        <p:nvSpPr>
-          <p:cNvPr id="7" name="Rectangle 6"/>
-          <p:cNvSpPr/>
-          <p:nvPr/>
-        </p:nvSpPr>
-        <p:spPr>
-          <a:xfrm>
-            <a:off x="457200" y="1143000"/>
-            <a:ext cx="4114800" cy="1097280"/>
+              <a:t>Three things to take away.</a:t>
+            </a:r>
+          </a:p>
+        </p:txBody>
+      </p:sp>
+      <p:sp>
+        <p:nvSpPr>
+          <p:cNvPr id="5" name="Rectangle 4"/>
+          <p:cNvSpPr/>
+          <p:nvPr/>
+        </p:nvSpPr>
+        <p:spPr>
+          <a:xfrm>
+            <a:off x="457200" y="1078992"/>
+            <a:ext cx="8229600" cy="960120"/>
           </a:xfrm>
           <a:prstGeom prst="rect">
             <a:avLst/>
@@ -10881,14 +12181,14 @@
       </p:sp>
       <p:sp>
         <p:nvSpPr>
-          <p:cNvPr id="8" name="Rectangle 7"/>
-          <p:cNvSpPr/>
-          <p:nvPr/>
-        </p:nvSpPr>
-        <p:spPr>
-          <a:xfrm>
-            <a:off x="594360" y="1280160"/>
-            <a:ext cx="457200" cy="457200"/>
+          <p:cNvPr id="6" name="Rectangle 5"/>
+          <p:cNvSpPr/>
+          <p:nvPr/>
+        </p:nvSpPr>
+        <p:spPr>
+          <a:xfrm>
+            <a:off x="457200" y="1078992"/>
+            <a:ext cx="1417320" cy="960120"/>
           </a:xfrm>
           <a:prstGeom prst="rect">
             <a:avLst/>
@@ -10924,14 +12224,14 @@
       </p:sp>
       <p:sp>
         <p:nvSpPr>
-          <p:cNvPr id="9" name="TextBox 8"/>
+          <p:cNvPr id="7" name="TextBox 6"/>
           <p:cNvSpPr txBox="1"/>
           <p:nvPr/>
         </p:nvSpPr>
         <p:spPr>
           <a:xfrm>
-            <a:off x="594360" y="1280160"/>
-            <a:ext cx="457200" cy="457200"/>
+            <a:off x="457200" y="1307592"/>
+            <a:ext cx="1417320" cy="502920"/>
           </a:xfrm>
           <a:prstGeom prst="rect">
             <a:avLst/>
@@ -10946,26 +12246,26 @@
           <a:p>
             <a:pPr algn="ctr"/>
             <a:r>
-              <a:rPr b="1" sz="1200">
+              <a:rPr b="1" sz="1100">
                 <a:solidFill>
                   <a:srgbClr val="0F1923"/>
                 </a:solidFill>
               </a:rPr>
-              <a:t>01</a:t>
-            </a:r>
-          </a:p>
-        </p:txBody>
-      </p:sp>
-      <p:sp>
-        <p:nvSpPr>
-          <p:cNvPr id="10" name="TextBox 9"/>
+              <a:t>WHAT WE BUILT</a:t>
+            </a:r>
+          </a:p>
+        </p:txBody>
+      </p:sp>
+      <p:sp>
+        <p:nvSpPr>
+          <p:cNvPr id="8" name="TextBox 7"/>
           <p:cNvSpPr txBox="1"/>
           <p:nvPr/>
         </p:nvSpPr>
         <p:spPr>
           <a:xfrm>
-            <a:off x="1143000" y="1234440"/>
-            <a:ext cx="3200400" cy="365760"/>
+            <a:off x="2057400" y="1170432"/>
+            <a:ext cx="6629400" cy="795528"/>
           </a:xfrm>
           <a:prstGeom prst="rect">
             <a:avLst/>
@@ -10980,60 +12280,26 @@
           <a:p>
             <a:pPr algn="l"/>
             <a:r>
-              <a:rPr b="1" sz="1200">
-                <a:solidFill>
-                  <a:srgbClr val="FFFFFF"/>
-                </a:solidFill>
-              </a:rPr>
-              <a:t>Static data cache</a:t>
-            </a:r>
-          </a:p>
-        </p:txBody>
-      </p:sp>
-      <p:sp>
-        <p:nvSpPr>
-          <p:cNvPr id="11" name="TextBox 10"/>
-          <p:cNvSpPr txBox="1"/>
-          <p:nvPr/>
-        </p:nvSpPr>
-        <p:spPr>
-          <a:xfrm>
-            <a:off x="1143000" y="1600200"/>
-            <a:ext cx="3200400" cy="548640"/>
-          </a:xfrm>
-          <a:prstGeom prst="rect">
-            <a:avLst/>
-          </a:prstGeom>
-          <a:noFill/>
-        </p:spPr>
-        <p:txBody>
-          <a:bodyPr wrap="square">
-            <a:spAutoFit/>
-          </a:bodyPr>
-          <a:lstStyle/>
-          <a:p>
-            <a:pPr algn="l"/>
-            <a:r>
-              <a:rPr b="0" sz="1000">
+              <a:rPr b="0" sz="1100">
                 <a:solidFill>
                   <a:srgbClr val="CBD5E1"/>
                 </a:solidFill>
               </a:rPr>
-              <a:t>Evidence reflects the last pull date. OFAC, court records, and GDELT go stale without a manual refresh.</a:t>
-            </a:r>
-          </a:p>
-        </p:txBody>
-      </p:sp>
-      <p:sp>
-        <p:nvSpPr>
-          <p:cNvPr id="12" name="Rectangle 11"/>
-          <p:cNvSpPr/>
-          <p:nvPr/>
-        </p:nvSpPr>
-        <p:spPr>
-          <a:xfrm>
-            <a:off x="457200" y="2377440"/>
-            <a:ext cx="4114800" cy="1097280"/>
+              <a:t>A seven-layer, multi-agent OSINT system that turns a plain-English query into a fully cited financial misconduct report — pulling from 4 public sources and returning 1,000+ evidence rows in under 3 seconds.</a:t>
+            </a:r>
+          </a:p>
+        </p:txBody>
+      </p:sp>
+      <p:sp>
+        <p:nvSpPr>
+          <p:cNvPr id="9" name="Rectangle 8"/>
+          <p:cNvSpPr/>
+          <p:nvPr/>
+        </p:nvSpPr>
+        <p:spPr>
+          <a:xfrm>
+            <a:off x="457200" y="2176272"/>
+            <a:ext cx="8229600" cy="960120"/>
           </a:xfrm>
           <a:prstGeom prst="rect">
             <a:avLst/>
@@ -11069,14 +12335,14 @@
       </p:sp>
       <p:sp>
         <p:nvSpPr>
-          <p:cNvPr id="13" name="Rectangle 12"/>
-          <p:cNvSpPr/>
-          <p:nvPr/>
-        </p:nvSpPr>
-        <p:spPr>
-          <a:xfrm>
-            <a:off x="594360" y="2514600"/>
-            <a:ext cx="457200" cy="457200"/>
+          <p:cNvPr id="10" name="Rectangle 9"/>
+          <p:cNvSpPr/>
+          <p:nvPr/>
+        </p:nvSpPr>
+        <p:spPr>
+          <a:xfrm>
+            <a:off x="457200" y="2176272"/>
+            <a:ext cx="1417320" cy="960120"/>
           </a:xfrm>
           <a:prstGeom prst="rect">
             <a:avLst/>
@@ -11112,14 +12378,14 @@
       </p:sp>
       <p:sp>
         <p:nvSpPr>
-          <p:cNvPr id="14" name="TextBox 13"/>
+          <p:cNvPr id="11" name="TextBox 10"/>
           <p:cNvSpPr txBox="1"/>
           <p:nvPr/>
         </p:nvSpPr>
         <p:spPr>
           <a:xfrm>
-            <a:off x="594360" y="2514600"/>
-            <a:ext cx="457200" cy="457200"/>
+            <a:off x="457200" y="2404872"/>
+            <a:ext cx="1417320" cy="502920"/>
           </a:xfrm>
           <a:prstGeom prst="rect">
             <a:avLst/>
@@ -11134,26 +12400,26 @@
           <a:p>
             <a:pPr algn="ctr"/>
             <a:r>
-              <a:rPr b="1" sz="1200">
+              <a:rPr b="1" sz="1100">
                 <a:solidFill>
                   <a:srgbClr val="0F1923"/>
                 </a:solidFill>
               </a:rPr>
-              <a:t>02</a:t>
-            </a:r>
-          </a:p>
-        </p:txBody>
-      </p:sp>
-      <p:sp>
-        <p:nvSpPr>
-          <p:cNvPr id="15" name="TextBox 14"/>
+              <a:t>WHAT WE PROVED</a:t>
+            </a:r>
+          </a:p>
+        </p:txBody>
+      </p:sp>
+      <p:sp>
+        <p:nvSpPr>
+          <p:cNvPr id="12" name="TextBox 11"/>
           <p:cNvSpPr txBox="1"/>
           <p:nvPr/>
         </p:nvSpPr>
         <p:spPr>
           <a:xfrm>
-            <a:off x="1143000" y="2468880"/>
-            <a:ext cx="3200400" cy="365760"/>
+            <a:off x="2057400" y="2267712"/>
+            <a:ext cx="6629400" cy="795528"/>
           </a:xfrm>
           <a:prstGeom prst="rect">
             <a:avLst/>
@@ -11168,60 +12434,26 @@
           <a:p>
             <a:pPr algn="l"/>
             <a:r>
-              <a:rPr b="1" sz="1200">
-                <a:solidFill>
-                  <a:srgbClr val="FFFFFF"/>
-                </a:solidFill>
-              </a:rPr>
-              <a:t>English-only news signal</a:t>
-            </a:r>
-          </a:p>
-        </p:txBody>
-      </p:sp>
-      <p:sp>
-        <p:nvSpPr>
-          <p:cNvPr id="16" name="TextBox 15"/>
-          <p:cNvSpPr txBox="1"/>
-          <p:nvPr/>
-        </p:nvSpPr>
-        <p:spPr>
-          <a:xfrm>
-            <a:off x="1143000" y="2834640"/>
-            <a:ext cx="3200400" cy="548640"/>
-          </a:xfrm>
-          <a:prstGeom prst="rect">
-            <a:avLst/>
-          </a:prstGeom>
-          <a:noFill/>
-        </p:spPr>
-        <p:txBody>
-          <a:bodyPr wrap="square">
-            <a:spAutoFit/>
-          </a:bodyPr>
-          <a:lstStyle/>
-          <a:p>
-            <a:pPr algn="l"/>
-            <a:r>
-              <a:rPr b="0" sz="1000">
+              <a:rPr b="0" sz="1100">
                 <a:solidFill>
                   <a:srgbClr val="CBD5E1"/>
                 </a:solidFill>
               </a:rPr>
-              <a:t>GDELT is filtered to English articles only. International adverse media in other languages is not captured.</a:t>
-            </a:r>
-          </a:p>
-        </p:txBody>
-      </p:sp>
-      <p:sp>
-        <p:nvSpPr>
-          <p:cNvPr id="17" name="Rectangle 16"/>
-          <p:cNvSpPr/>
-          <p:nvPr/>
-        </p:nvSpPr>
-        <p:spPr>
-          <a:xfrm>
-            <a:off x="457200" y="3611880"/>
-            <a:ext cx="4114800" cy="1097280"/>
+              <a:t>3,100× faster than a manual analyst. 97.7% citation rate across 5 entities in 3 industries. Full 4/4 source coverage every run. Verified by 219 unit tests across all 8 system layers.</a:t>
+            </a:r>
+          </a:p>
+        </p:txBody>
+      </p:sp>
+      <p:sp>
+        <p:nvSpPr>
+          <p:cNvPr id="13" name="Rectangle 12"/>
+          <p:cNvSpPr/>
+          <p:nvPr/>
+        </p:nvSpPr>
+        <p:spPr>
+          <a:xfrm>
+            <a:off x="457200" y="3273552"/>
+            <a:ext cx="8229600" cy="960120"/>
           </a:xfrm>
           <a:prstGeom prst="rect">
             <a:avLst/>
@@ -11257,14 +12489,14 @@
       </p:sp>
       <p:sp>
         <p:nvSpPr>
-          <p:cNvPr id="18" name="Rectangle 17"/>
-          <p:cNvSpPr/>
-          <p:nvPr/>
-        </p:nvSpPr>
-        <p:spPr>
-          <a:xfrm>
-            <a:off x="594360" y="3749040"/>
-            <a:ext cx="457200" cy="457200"/>
+          <p:cNvPr id="14" name="Rectangle 13"/>
+          <p:cNvSpPr/>
+          <p:nvPr/>
+        </p:nvSpPr>
+        <p:spPr>
+          <a:xfrm>
+            <a:off x="457200" y="3273552"/>
+            <a:ext cx="1417320" cy="960120"/>
           </a:xfrm>
           <a:prstGeom prst="rect">
             <a:avLst/>
@@ -11300,14 +12532,14 @@
       </p:sp>
       <p:sp>
         <p:nvSpPr>
-          <p:cNvPr id="19" name="TextBox 18"/>
+          <p:cNvPr id="15" name="TextBox 14"/>
           <p:cNvSpPr txBox="1"/>
           <p:nvPr/>
         </p:nvSpPr>
         <p:spPr>
           <a:xfrm>
-            <a:off x="594360" y="3749040"/>
-            <a:ext cx="457200" cy="457200"/>
+            <a:off x="457200" y="3502152"/>
+            <a:ext cx="1417320" cy="502920"/>
           </a:xfrm>
           <a:prstGeom prst="rect">
             <a:avLst/>
@@ -11322,26 +12554,26 @@
           <a:p>
             <a:pPr algn="ctr"/>
             <a:r>
-              <a:rPr b="1" sz="1200">
+              <a:rPr b="1" sz="1100">
                 <a:solidFill>
                   <a:srgbClr val="0F1923"/>
                 </a:solidFill>
               </a:rPr>
-              <a:t>03</a:t>
-            </a:r>
-          </a:p>
-        </p:txBody>
-      </p:sp>
-      <p:sp>
-        <p:nvSpPr>
-          <p:cNvPr id="20" name="TextBox 19"/>
+              <a:t>WHAT'S NEXT</a:t>
+            </a:r>
+          </a:p>
+        </p:txBody>
+      </p:sp>
+      <p:sp>
+        <p:nvSpPr>
+          <p:cNvPr id="16" name="TextBox 15"/>
           <p:cNvSpPr txBox="1"/>
           <p:nvPr/>
         </p:nvSpPr>
         <p:spPr>
           <a:xfrm>
-            <a:off x="1143000" y="3703320"/>
-            <a:ext cx="3200400" cy="365760"/>
+            <a:off x="2057400" y="3364992"/>
+            <a:ext cx="6629400" cy="795528"/>
           </a:xfrm>
           <a:prstGeom prst="rect">
             <a:avLst/>
@@ -11356,26 +12588,26 @@
           <a:p>
             <a:pPr algn="l"/>
             <a:r>
-              <a:rPr b="1" sz="1200">
-                <a:solidFill>
-                  <a:srgbClr val="FFFFFF"/>
-                </a:solidFill>
-              </a:rPr>
-              <a:t>Narrative not formally verified</a:t>
-            </a:r>
-          </a:p>
-        </p:txBody>
-      </p:sp>
-      <p:sp>
-        <p:nvSpPr>
-          <p:cNvPr id="21" name="TextBox 20"/>
+              <a:rPr b="0" sz="1100">
+                <a:solidFill>
+                  <a:srgbClr val="CBD5E1"/>
+                </a:solidFill>
+              </a:rPr>
+              <a:t>Automated nightly data refresh · on-demand resolution for any public company · private and international source integration (OpenCorporates, Dun &amp; Bradstreet) · multi-language adverse media support.</a:t>
+            </a:r>
+          </a:p>
+        </p:txBody>
+      </p:sp>
+      <p:sp>
+        <p:nvSpPr>
+          <p:cNvPr id="17" name="TextBox 16"/>
           <p:cNvSpPr txBox="1"/>
           <p:nvPr/>
         </p:nvSpPr>
         <p:spPr>
           <a:xfrm>
-            <a:off x="1143000" y="4069080"/>
-            <a:ext cx="3200400" cy="548640"/>
+            <a:off x="8229600" y="4709160"/>
+            <a:ext cx="640080" cy="274320"/>
           </a:xfrm>
           <a:prstGeom prst="rect">
             <a:avLst/>
@@ -11388,612 +12620,14 @@
           </a:bodyPr>
           <a:lstStyle/>
           <a:p>
-            <a:pPr algn="l"/>
+            <a:pPr algn="r"/>
             <a:r>
               <a:rPr b="0" sz="1000">
                 <a:solidFill>
-                  <a:srgbClr val="CBD5E1"/>
-                </a:solidFill>
-              </a:rPr>
-              <a:t>The LLM narrative is contract-bound but not sentence-level cross-checked against individual evidence rows.</a:t>
-            </a:r>
-          </a:p>
-        </p:txBody>
-      </p:sp>
-      <p:sp>
-        <p:nvSpPr>
-          <p:cNvPr id="22" name="Rectangle 21"/>
-          <p:cNvSpPr/>
-          <p:nvPr/>
-        </p:nvSpPr>
-        <p:spPr>
-          <a:xfrm>
-            <a:off x="4846320" y="1143000"/>
-            <a:ext cx="4114800" cy="1097280"/>
-          </a:xfrm>
-          <a:prstGeom prst="rect">
-            <a:avLst/>
-          </a:prstGeom>
-          <a:solidFill>
-            <a:srgbClr val="1E3A52"/>
-          </a:solidFill>
-          <a:ln>
-            <a:noFill/>
-          </a:ln>
-        </p:spPr>
-        <p:style>
-          <a:lnRef idx="1">
-            <a:schemeClr val="accent1"/>
-          </a:lnRef>
-          <a:fillRef idx="3">
-            <a:schemeClr val="accent1"/>
-          </a:fillRef>
-          <a:effectRef idx="2">
-            <a:schemeClr val="accent1"/>
-          </a:effectRef>
-          <a:fontRef idx="minor">
-            <a:schemeClr val="lt1"/>
-          </a:fontRef>
-        </p:style>
-        <p:txBody>
-          <a:bodyPr rtlCol="0" anchor="ctr"/>
-          <a:lstStyle/>
-          <a:p>
-            <a:pPr algn="ctr"/>
-          </a:p>
-        </p:txBody>
-      </p:sp>
-      <p:sp>
-        <p:nvSpPr>
-          <p:cNvPr id="23" name="Rectangle 22"/>
-          <p:cNvSpPr/>
-          <p:nvPr/>
-        </p:nvSpPr>
-        <p:spPr>
-          <a:xfrm>
-            <a:off x="4983480" y="1280160"/>
-            <a:ext cx="457200" cy="457200"/>
-          </a:xfrm>
-          <a:prstGeom prst="rect">
-            <a:avLst/>
-          </a:prstGeom>
-          <a:solidFill>
-            <a:srgbClr val="00B4D8"/>
-          </a:solidFill>
-          <a:ln>
-            <a:noFill/>
-          </a:ln>
-        </p:spPr>
-        <p:style>
-          <a:lnRef idx="1">
-            <a:schemeClr val="accent1"/>
-          </a:lnRef>
-          <a:fillRef idx="3">
-            <a:schemeClr val="accent1"/>
-          </a:fillRef>
-          <a:effectRef idx="2">
-            <a:schemeClr val="accent1"/>
-          </a:effectRef>
-          <a:fontRef idx="minor">
-            <a:schemeClr val="lt1"/>
-          </a:fontRef>
-        </p:style>
-        <p:txBody>
-          <a:bodyPr rtlCol="0" anchor="ctr"/>
-          <a:lstStyle/>
-          <a:p>
-            <a:pPr algn="ctr"/>
-          </a:p>
-        </p:txBody>
-      </p:sp>
-      <p:sp>
-        <p:nvSpPr>
-          <p:cNvPr id="24" name="TextBox 23"/>
-          <p:cNvSpPr txBox="1"/>
-          <p:nvPr/>
-        </p:nvSpPr>
-        <p:spPr>
-          <a:xfrm>
-            <a:off x="4983480" y="1280160"/>
-            <a:ext cx="457200" cy="457200"/>
-          </a:xfrm>
-          <a:prstGeom prst="rect">
-            <a:avLst/>
-          </a:prstGeom>
-          <a:noFill/>
-        </p:spPr>
-        <p:txBody>
-          <a:bodyPr wrap="square">
-            <a:spAutoFit/>
-          </a:bodyPr>
-          <a:lstStyle/>
-          <a:p>
-            <a:pPr algn="ctr"/>
-            <a:r>
-              <a:rPr b="1" sz="1200">
-                <a:solidFill>
-                  <a:srgbClr val="0F1923"/>
-                </a:solidFill>
-              </a:rPr>
-              <a:t>04</a:t>
-            </a:r>
-          </a:p>
-        </p:txBody>
-      </p:sp>
-      <p:sp>
-        <p:nvSpPr>
-          <p:cNvPr id="25" name="TextBox 24"/>
-          <p:cNvSpPr txBox="1"/>
-          <p:nvPr/>
-        </p:nvSpPr>
-        <p:spPr>
-          <a:xfrm>
-            <a:off x="5532120" y="1234440"/>
-            <a:ext cx="3200400" cy="365760"/>
-          </a:xfrm>
-          <a:prstGeom prst="rect">
-            <a:avLst/>
-          </a:prstGeom>
-          <a:noFill/>
-        </p:spPr>
-        <p:txBody>
-          <a:bodyPr wrap="square">
-            <a:spAutoFit/>
-          </a:bodyPr>
-          <a:lstStyle/>
-          <a:p>
-            <a:pPr algn="l"/>
-            <a:r>
-              <a:rPr b="1" sz="1200">
-                <a:solidFill>
-                  <a:srgbClr val="FFFFFF"/>
-                </a:solidFill>
-              </a:rPr>
-              <a:t>Scheduled data refresh</a:t>
-            </a:r>
-          </a:p>
-        </p:txBody>
-      </p:sp>
-      <p:sp>
-        <p:nvSpPr>
-          <p:cNvPr id="26" name="TextBox 25"/>
-          <p:cNvSpPr txBox="1"/>
-          <p:nvPr/>
-        </p:nvSpPr>
-        <p:spPr>
-          <a:xfrm>
-            <a:off x="5532120" y="1600200"/>
-            <a:ext cx="3200400" cy="548640"/>
-          </a:xfrm>
-          <a:prstGeom prst="rect">
-            <a:avLst/>
-          </a:prstGeom>
-          <a:noFill/>
-        </p:spPr>
-        <p:txBody>
-          <a:bodyPr wrap="square">
-            <a:spAutoFit/>
-          </a:bodyPr>
-          <a:lstStyle/>
-          <a:p>
-            <a:pPr algn="l"/>
-            <a:r>
-              <a:rPr b="0" sz="1000">
-                <a:solidFill>
-                  <a:srgbClr val="CBD5E1"/>
-                </a:solidFill>
-              </a:rPr>
-              <a:t>Automate nightly pulls for all four sources so every investigation reflects the current day's data.</a:t>
-            </a:r>
-          </a:p>
-        </p:txBody>
-      </p:sp>
-      <p:sp>
-        <p:nvSpPr>
-          <p:cNvPr id="27" name="Rectangle 26"/>
-          <p:cNvSpPr/>
-          <p:nvPr/>
-        </p:nvSpPr>
-        <p:spPr>
-          <a:xfrm>
-            <a:off x="4846320" y="2377440"/>
-            <a:ext cx="4114800" cy="1097280"/>
-          </a:xfrm>
-          <a:prstGeom prst="rect">
-            <a:avLst/>
-          </a:prstGeom>
-          <a:solidFill>
-            <a:srgbClr val="1E3A52"/>
-          </a:solidFill>
-          <a:ln>
-            <a:noFill/>
-          </a:ln>
-        </p:spPr>
-        <p:style>
-          <a:lnRef idx="1">
-            <a:schemeClr val="accent1"/>
-          </a:lnRef>
-          <a:fillRef idx="3">
-            <a:schemeClr val="accent1"/>
-          </a:fillRef>
-          <a:effectRef idx="2">
-            <a:schemeClr val="accent1"/>
-          </a:effectRef>
-          <a:fontRef idx="minor">
-            <a:schemeClr val="lt1"/>
-          </a:fontRef>
-        </p:style>
-        <p:txBody>
-          <a:bodyPr rtlCol="0" anchor="ctr"/>
-          <a:lstStyle/>
-          <a:p>
-            <a:pPr algn="ctr"/>
-          </a:p>
-        </p:txBody>
-      </p:sp>
-      <p:sp>
-        <p:nvSpPr>
-          <p:cNvPr id="28" name="Rectangle 27"/>
-          <p:cNvSpPr/>
-          <p:nvPr/>
-        </p:nvSpPr>
-        <p:spPr>
-          <a:xfrm>
-            <a:off x="4983480" y="2514600"/>
-            <a:ext cx="457200" cy="457200"/>
-          </a:xfrm>
-          <a:prstGeom prst="rect">
-            <a:avLst/>
-          </a:prstGeom>
-          <a:solidFill>
-            <a:srgbClr val="00B4D8"/>
-          </a:solidFill>
-          <a:ln>
-            <a:noFill/>
-          </a:ln>
-        </p:spPr>
-        <p:style>
-          <a:lnRef idx="1">
-            <a:schemeClr val="accent1"/>
-          </a:lnRef>
-          <a:fillRef idx="3">
-            <a:schemeClr val="accent1"/>
-          </a:fillRef>
-          <a:effectRef idx="2">
-            <a:schemeClr val="accent1"/>
-          </a:effectRef>
-          <a:fontRef idx="minor">
-            <a:schemeClr val="lt1"/>
-          </a:fontRef>
-        </p:style>
-        <p:txBody>
-          <a:bodyPr rtlCol="0" anchor="ctr"/>
-          <a:lstStyle/>
-          <a:p>
-            <a:pPr algn="ctr"/>
-          </a:p>
-        </p:txBody>
-      </p:sp>
-      <p:sp>
-        <p:nvSpPr>
-          <p:cNvPr id="29" name="TextBox 28"/>
-          <p:cNvSpPr txBox="1"/>
-          <p:nvPr/>
-        </p:nvSpPr>
-        <p:spPr>
-          <a:xfrm>
-            <a:off x="4983480" y="2514600"/>
-            <a:ext cx="457200" cy="457200"/>
-          </a:xfrm>
-          <a:prstGeom prst="rect">
-            <a:avLst/>
-          </a:prstGeom>
-          <a:noFill/>
-        </p:spPr>
-        <p:txBody>
-          <a:bodyPr wrap="square">
-            <a:spAutoFit/>
-          </a:bodyPr>
-          <a:lstStyle/>
-          <a:p>
-            <a:pPr algn="ctr"/>
-            <a:r>
-              <a:rPr b="1" sz="1200">
-                <a:solidFill>
-                  <a:srgbClr val="0F1923"/>
-                </a:solidFill>
-              </a:rPr>
-              <a:t>05</a:t>
-            </a:r>
-          </a:p>
-        </p:txBody>
-      </p:sp>
-      <p:sp>
-        <p:nvSpPr>
-          <p:cNvPr id="30" name="TextBox 29"/>
-          <p:cNvSpPr txBox="1"/>
-          <p:nvPr/>
-        </p:nvSpPr>
-        <p:spPr>
-          <a:xfrm>
-            <a:off x="5532120" y="2468880"/>
-            <a:ext cx="3200400" cy="365760"/>
-          </a:xfrm>
-          <a:prstGeom prst="rect">
-            <a:avLst/>
-          </a:prstGeom>
-          <a:noFill/>
-        </p:spPr>
-        <p:txBody>
-          <a:bodyPr wrap="square">
-            <a:spAutoFit/>
-          </a:bodyPr>
-          <a:lstStyle/>
-          <a:p>
-            <a:pPr algn="l"/>
-            <a:r>
-              <a:rPr b="1" sz="1200">
-                <a:solidFill>
-                  <a:srgbClr val="FFFFFF"/>
-                </a:solidFill>
-              </a:rPr>
-              <a:t>On-demand entity coverage</a:t>
-            </a:r>
-          </a:p>
-        </p:txBody>
-      </p:sp>
-      <p:sp>
-        <p:nvSpPr>
-          <p:cNvPr id="31" name="TextBox 30"/>
-          <p:cNvSpPr txBox="1"/>
-          <p:nvPr/>
-        </p:nvSpPr>
-        <p:spPr>
-          <a:xfrm>
-            <a:off x="5532120" y="2834640"/>
-            <a:ext cx="3200400" cy="548640"/>
-          </a:xfrm>
-          <a:prstGeom prst="rect">
-            <a:avLst/>
-          </a:prstGeom>
-          <a:noFill/>
-        </p:spPr>
-        <p:txBody>
-          <a:bodyPr wrap="square">
-            <a:spAutoFit/>
-          </a:bodyPr>
-          <a:lstStyle/>
-          <a:p>
-            <a:pPr algn="l"/>
-            <a:r>
-              <a:rPr b="0" sz="1000">
-                <a:solidFill>
-                  <a:srgbClr val="CBD5E1"/>
-                </a:solidFill>
-              </a:rPr>
-              <a:t>Resolve and pull any public company at query time via SEC EDGAR, removing the five-entity cache limit.</a:t>
-            </a:r>
-          </a:p>
-        </p:txBody>
-      </p:sp>
-      <p:sp>
-        <p:nvSpPr>
-          <p:cNvPr id="32" name="Rectangle 31"/>
-          <p:cNvSpPr/>
-          <p:nvPr/>
-        </p:nvSpPr>
-        <p:spPr>
-          <a:xfrm>
-            <a:off x="4846320" y="3611880"/>
-            <a:ext cx="4114800" cy="1097280"/>
-          </a:xfrm>
-          <a:prstGeom prst="rect">
-            <a:avLst/>
-          </a:prstGeom>
-          <a:solidFill>
-            <a:srgbClr val="1E3A52"/>
-          </a:solidFill>
-          <a:ln>
-            <a:noFill/>
-          </a:ln>
-        </p:spPr>
-        <p:style>
-          <a:lnRef idx="1">
-            <a:schemeClr val="accent1"/>
-          </a:lnRef>
-          <a:fillRef idx="3">
-            <a:schemeClr val="accent1"/>
-          </a:fillRef>
-          <a:effectRef idx="2">
-            <a:schemeClr val="accent1"/>
-          </a:effectRef>
-          <a:fontRef idx="minor">
-            <a:schemeClr val="lt1"/>
-          </a:fontRef>
-        </p:style>
-        <p:txBody>
-          <a:bodyPr rtlCol="0" anchor="ctr"/>
-          <a:lstStyle/>
-          <a:p>
-            <a:pPr algn="ctr"/>
-          </a:p>
-        </p:txBody>
-      </p:sp>
-      <p:sp>
-        <p:nvSpPr>
-          <p:cNvPr id="33" name="Rectangle 32"/>
-          <p:cNvSpPr/>
-          <p:nvPr/>
-        </p:nvSpPr>
-        <p:spPr>
-          <a:xfrm>
-            <a:off x="4983480" y="3749040"/>
-            <a:ext cx="457200" cy="457200"/>
-          </a:xfrm>
-          <a:prstGeom prst="rect">
-            <a:avLst/>
-          </a:prstGeom>
-          <a:solidFill>
-            <a:srgbClr val="00B4D8"/>
-          </a:solidFill>
-          <a:ln>
-            <a:noFill/>
-          </a:ln>
-        </p:spPr>
-        <p:style>
-          <a:lnRef idx="1">
-            <a:schemeClr val="accent1"/>
-          </a:lnRef>
-          <a:fillRef idx="3">
-            <a:schemeClr val="accent1"/>
-          </a:fillRef>
-          <a:effectRef idx="2">
-            <a:schemeClr val="accent1"/>
-          </a:effectRef>
-          <a:fontRef idx="minor">
-            <a:schemeClr val="lt1"/>
-          </a:fontRef>
-        </p:style>
-        <p:txBody>
-          <a:bodyPr rtlCol="0" anchor="ctr"/>
-          <a:lstStyle/>
-          <a:p>
-            <a:pPr algn="ctr"/>
-          </a:p>
-        </p:txBody>
-      </p:sp>
-      <p:sp>
-        <p:nvSpPr>
-          <p:cNvPr id="34" name="TextBox 33"/>
-          <p:cNvSpPr txBox="1"/>
-          <p:nvPr/>
-        </p:nvSpPr>
-        <p:spPr>
-          <a:xfrm>
-            <a:off x="4983480" y="3749040"/>
-            <a:ext cx="457200" cy="457200"/>
-          </a:xfrm>
-          <a:prstGeom prst="rect">
-            <a:avLst/>
-          </a:prstGeom>
-          <a:noFill/>
-        </p:spPr>
-        <p:txBody>
-          <a:bodyPr wrap="square">
-            <a:spAutoFit/>
-          </a:bodyPr>
-          <a:lstStyle/>
-          <a:p>
-            <a:pPr algn="ctr"/>
-            <a:r>
-              <a:rPr b="1" sz="1200">
-                <a:solidFill>
-                  <a:srgbClr val="0F1923"/>
-                </a:solidFill>
-              </a:rPr>
-              <a:t>06</a:t>
-            </a:r>
-          </a:p>
-        </p:txBody>
-      </p:sp>
-      <p:sp>
-        <p:nvSpPr>
-          <p:cNvPr id="35" name="TextBox 34"/>
-          <p:cNvSpPr txBox="1"/>
-          <p:nvPr/>
-        </p:nvSpPr>
-        <p:spPr>
-          <a:xfrm>
-            <a:off x="5532120" y="3703320"/>
-            <a:ext cx="3200400" cy="365760"/>
-          </a:xfrm>
-          <a:prstGeom prst="rect">
-            <a:avLst/>
-          </a:prstGeom>
-          <a:noFill/>
-        </p:spPr>
-        <p:txBody>
-          <a:bodyPr wrap="square">
-            <a:spAutoFit/>
-          </a:bodyPr>
-          <a:lstStyle/>
-          <a:p>
-            <a:pPr algn="l"/>
-            <a:r>
-              <a:rPr b="1" sz="1200">
-                <a:solidFill>
-                  <a:srgbClr val="FFFFFF"/>
-                </a:solidFill>
-              </a:rPr>
-              <a:t>Private source integration</a:t>
-            </a:r>
-          </a:p>
-        </p:txBody>
-      </p:sp>
-      <p:sp>
-        <p:nvSpPr>
-          <p:cNvPr id="36" name="TextBox 35"/>
-          <p:cNvSpPr txBox="1"/>
-          <p:nvPr/>
-        </p:nvSpPr>
-        <p:spPr>
-          <a:xfrm>
-            <a:off x="5532120" y="4069080"/>
-            <a:ext cx="3200400" cy="548640"/>
-          </a:xfrm>
-          <a:prstGeom prst="rect">
-            <a:avLst/>
-          </a:prstGeom>
-          <a:noFill/>
-        </p:spPr>
-        <p:txBody>
-          <a:bodyPr wrap="square">
-            <a:spAutoFit/>
-          </a:bodyPr>
-          <a:lstStyle/>
-          <a:p>
-            <a:pPr algn="l"/>
-            <a:r>
-              <a:rPr b="0" sz="1000">
-                <a:solidFill>
-                  <a:srgbClr val="CBD5E1"/>
-                </a:solidFill>
-              </a:rPr>
-              <a:t>Add licensed data (OpenCorporates, Dun &amp; Bradstreet) to support non-public and international entities.</a:t>
-            </a:r>
-          </a:p>
-        </p:txBody>
-      </p:sp>
-      <p:sp>
-        <p:nvSpPr>
-          <p:cNvPr id="37" name="TextBox 36"/>
-          <p:cNvSpPr txBox="1"/>
-          <p:nvPr/>
-        </p:nvSpPr>
-        <p:spPr>
-          <a:xfrm>
-            <a:off x="8229600" y="4709160"/>
-            <a:ext cx="640080" cy="274320"/>
-          </a:xfrm>
-          <a:prstGeom prst="rect">
-            <a:avLst/>
-          </a:prstGeom>
-          <a:noFill/>
-        </p:spPr>
-        <p:txBody>
-          <a:bodyPr wrap="square">
-            <a:spAutoFit/>
-          </a:bodyPr>
-          <a:lstStyle/>
-          <a:p>
-            <a:pPr algn="r"/>
-            <a:r>
-              <a:rPr b="0" sz="1000">
-                <a:solidFill>
                   <a:srgbClr val="64748B"/>
                 </a:solidFill>
               </a:rPr>
-              <a:t>14</a:t>
+              <a:t>15</a:t>
             </a:r>
           </a:p>
         </p:txBody>

</xml_diff>